<commit_message>
Rewrite pitch copy around buyers, paid outcomes and Dani proposal
</commit_message>
<xml_diff>
--- a/pitch-deck.pptx
+++ b/pitch-deck.pptx
@@ -540,7 +540,7 @@
           <a:lstStyle/>
           <a:p>
             <a:r>
-              <a:t>A máquina é uma base de produção compartilhada para toda a AUMI: conteúdo, software, atendimento, produtos digitais e mapas de TI. Hoje discutimos uma proposta, não uma empresa com esses contratos já vendidos. O objetivo é validar compradores, custos e execução antes de liberar compra e expansão.</a:t>
+              <a:t>Dani, a proposta é construir uma operação de IA que trabalhe nas entregas da AUMI e nos nossos próprios produtos. Conteúdo, desenvolvimento, atendimento e Topologic podem usar a mesma base, com processos distintos. A compra da máquina faz parte desse plano; sozinha, não cria clientes. Estas são ofertas a validar, não contratos já conquistados.</a:t>
             </a:r>
           </a:p>
           <a:p/>
@@ -622,7 +622,7 @@
           <a:lstStyle/>
           <a:p>
             <a:r>
-              <a:t>DGX Spark GB10, 128GB de memória unificada, 20 núcleos ARM, 4TB provisionados e 10GbE. A NVIDIA publica playbooks oficiais de vLLM e SGLang para Spark. São alternativas conforme modelo e carga, não duas capacidades somadas. Autenticação, isolamento, fila, permissões mínimas e backup fazem parte da implantação a validar. Imagem, áudio e vídeo exigem pipelines próprios. Aplicação, checkout e entrega digital ficam fora da máquina local. R$65 mil é provisão, não cotação brasileira. Uma máquina não tem redundância.</a:t>
+              <a:t>A razão proposta para a DGX é compartilhar a execução de modelos entre as frentes da AUMI. Isso permite organizar modelos, contexto e filas próprios, mas não comprova economia ou capacidade. DGX Spark GB10, 128GB, 4TB provisionados e 10GbE. NVIDIA documenta vLLM e SGLang, alternativas conforme a carga. Texto e código podem usar serving; imagem, áudio e vídeo exigem pipelines próprios. Checkout, aplicação e backup separado ficam fora. Segurança, isolamento e carga precisam ser homologados. Uma máquina não tem redundância; R$65 mil é provisão sem cotação brasileira.</a:t>
             </a:r>
           </a:p>
           <a:p/>
@@ -704,7 +704,7 @@
           <a:lstStyle/>
           <a:p>
             <a:r>
-              <a:t>Precisamos medir a carga real, não inferir capacidade por memória ou por um playbook do fabricante. Atendimento tem prioridade planejada; conteúdo e tarefas longas podem ser agendados. A decisão depende de latência, qualidade, concorrência, memória, custo e tempo humano. Uma segunda máquina só entra depois de utilização, vendas e capacidade justificarem. Não traduzimos horas humanas em tokens por segundo.</a:t>
+              <a:t>Uma infraestrutura compartilhada tem fila e limites. Atendimento terá prioridade planejada; conteúdo e código podem ser agendados. Precisamos medir tempo humano, latência, concorrência, qualidade e custo por tarefa. Não temos benchmark de capacidade para prometer clientes simultâneos ou SLA. Mais hardware só se justifica com demanda, utilização e caixa.</a:t>
             </a:r>
           </a:p>
           <a:p/>
@@ -786,13 +786,13 @@
           <a:lstStyle/>
           <a:p>
             <a:r>
-              <a:t>Hotmart e Teachable reportaram 21 milhões de consumidores globais nos 12 meses anteriores a março de 2024. LATAM sem Brasil teve crescimento de 50% em GMV entre 2022 e 2023, segundo a empresa. Flexera 2025: 84% de mais de 750 profissionais globais apontam gestão do gasto cloud como principal desafio. Nada disso é nosso TAM ou prova de intenção de compra. Conteúdo concorre com gratuito, criadores e marketplaces; automação e atendimento com SaaS e agências; TI com consultorias, draw.io, LeanIX e ServiceNow.</a:t>
+              <a:t>Não alegamos exclusividade ou superioridade comprovada. A hipótese comercial é vender execução contextualizada e revisada, em vez de apenas acesso a uma ferramenta. Concorrentes incluem profissionais, agências, SaaS, consultorias, draw.io, LeanIX e ServiceNow. O piloto pago precisa demonstrar valor no caso concreto. Dados de mercado permanecem nas referências; não substituem validação de compra.</a:t>
             </a:r>
           </a:p>
           <a:p/>
           <a:p>
             <a:r>
-              <a:t>Fontes públicas: Hotmart, 21/03/2024; Flexera, 19/03/2025. Não são demanda validada da AUMI.</a:t>
+              <a:t>Proposta para discussão • 02/10/2026 • Sem promessa de retorno</a:t>
             </a:r>
           </a:p>
           <a:p/>
@@ -868,7 +868,7 @@
           <a:lstStyle/>
           <a:p>
             <a:r>
-              <a:t>Proposta a implantar, não painel já integrado. Fontes autorizadas: checkout, banco, anúncios, CRM e projetos. Os agentes reconciliam receitas, estornos, custos, horas e caixa com evidência. Painel somente leitura para sócios, relatório diário, reunião semanal e prestação mensal. AUMI e Dani aprovam orçamento e despesas relevantes, com limites a formalizar. Pagamentos, contratos, publicação e compras exigem pessoa responsável. Agentes não têm acesso financeiro irrestrito.</a:t>
+              <a:t>Governança proposta a implantar. Painel de leitura para sócios, relatório diário, reunião semanal e prestação mensal. Dados de checkout, banco, anúncios, CRM e projetos com autorização. Agentes ajudam a reconciliar receitas, estornos, custos e horas, com fonte e alerta. Orçamento e despesas relevantes passam por aprovação conjunta com limites formalizados. Dinheiro, contratos, publicação e compras ficam sob responsabilidade humana.</a:t>
             </a:r>
           </a:p>
           <a:p/>
@@ -950,7 +950,7 @@
           <a:lstStyle/>
           <a:p>
             <a:r>
-              <a:t>Contribuição é o que sobra depois dos custos variáveis. Ainda precisa pagar fixos e não é lucro nem caixa. Conteúdo contribui R$2 mil por cliente/mês; código R$6.600 por projeto; atendimento R$1.630 por mês mais R$1 mil por setup; mapa R$9.600 por projeto. Loja contribui USD7,31628 por pedido aprovado a CAC10. Horas diretas são variáveis, separadas da equipe fixa de pesquisa e estrutura. Todas são hipóteses; impostos precisam de contador.</a:t>
+              <a:t>Estes valores descontam custos variáveis, incluindo trabalho direto, tributos e comercial. Ainda não são lucro: precisam pagar fixos. Conteúdo: R$2 mil/cliente-mês; código: R$6.600/projeto; atendimento: R$1.630/mês e R$1 mil/setup; mapa: R$9.600/projeto; loja: USD7,31628/pedido com CAC10. Hipóteses gerenciais, com regime tributário a validar. Equipe fixa não substitui as horas variáveis de entrega.</a:t>
             </a:r>
           </a:p>
           <a:p/>
@@ -1032,7 +1032,7 @@
           <a:lstStyle/>
           <a:p>
             <a:r>
-              <a:t>Estes cenários incluem loja, mapas, conteúdo, código e atendimento. Não são probabilidades nem pipeline existente. Capital inclui M0 dentro do pico de déficit, mais R$126 mil de reserva, arredondado para cima em R$10 mil. Payback é o primeiro mês de fluxo acumulado não negativo, sem aportes. Não é o retorno de Dani. O fluxo de 24 meses só pode ser executado com capital e capacidade suficientes. Valores do novo resumo financeiro ampliado.</a:t>
+              <a:t>Projeções das cinco frentes, não contratos ou probabilidades. Capital inclui M0 no pico de déficit, reserva de R$126 mil e arredondamento para cima em R$10 mil. Payback é o primeiro mês de fluxo acumulado não negativo sem aportes. Não é devolução do aporte de Dani. Cada cenário depende de aquisição, execução e financiamento integral. O conservador não recupera o investimento em 24 meses.</a:t>
             </a:r>
           </a:p>
           <a:p/>
@@ -1114,7 +1114,7 @@
           <a:lstStyle/>
           <a:p>
             <a:r>
-              <a:t>M0: R$76 mil de equipamentos e R$24 mil de preparação. Equipamentos: DGX65k, proteção4k, rede2k, backup3k e periféricos2k. Preparação: jurídico12k e segurança12k. Fixos37k por mês no ano1 e42k no ano2. Um cheque100k deixa zero após M0;150k deixa50k e200k deixa100k. Isso equivale a0/1,35/2,70 meses só de fixos sem vendas, não ao fôlego completo com aquisição e entregas. O cenário-base ampliado exige R$ 430.000 no total; inclui reserva126k. Não somar M0 novamente ao pico de déficit.</a:t>
+              <a:t>M0 de R$100 mil: R$76 mil de equipamentos e R$24 mil de preparação. DGX 65 mil, proteção 4 mil, rede 2 mil, backup 3 mil, periféricos 2 mil; jurídico 12 mil e segurança 12 mil. Fixos de R$37 mil/mês no ano 1 e R$42 mil no ano 2. Cheques de R$100/150/200 mil deixam R$0/50/100 mil depois de M0, antes dos custos operacionais. Cenário-base exige R$430 mil totais com reserva de R$126 mil; M0 já incluído. Cotação brasileira pendente. Não é uma solicitação de aporte integral desse valor à Dani.</a:t>
             </a:r>
           </a:p>
           <a:p/>
@@ -1196,7 +1196,7 @@
           <a:lstStyle/>
           <a:p>
             <a:r>
-              <a:t>Retorno do negócio usa o fluxo do portfólio inteiro. Retorno do equipamento usa apenas benefício líquido incremental frente a operar sem compra, por exemplo com APIs alternativas. Não atribuir toda receita à DGX. Benefício incremental é margem adicional mais economia efetiva menos custos incrementais. Horas poupadas não viram caixa automaticamente. Exemplo aritmético: R$76 mil divididos por R$5 mil por mês são15,2 meses; não é benchmark nem resultado do modelo, não inclui rampa, juros ou valor residual. Dani tem retorno indefinido porque aporte e distribuição não foram acordados.</a:t>
+              <a:t>O negócio se paga pelo fluxo do portfólio após custos. A máquina compensa pelo benefício líquido adicional frente a operar sem compra, incluindo APIs. Só entram margem adicional e economia efetiva, menos custos incrementais. Não atribuir toda receita à DGX, nem converter horas poupadas automaticamente em caixa. Exemplo: R$76 mil / R$5 mil por mês = 15,2 meses, sem rampa, juros ou valor residual. Não é benchmark ou previsão. Retorno de Dani depende do aporte e distribuição ainda não acordados.</a:t>
             </a:r>
           </a:p>
           <a:p/>
@@ -1278,7 +1278,7 @@
           <a:lstStyle/>
           <a:p>
             <a:r>
-              <a:t>Dias1–30: conversar com10 compradores de nichos e5 contatos de TI, escolher até3 nichos e uma oferta B2B prioritária. Dias31–60: preparar até3 ofertas testáveis, validar checkout, dados, entrega e segurança; homologar modelo/carga. Dias61–90: alvo condicional50 vendas de loja e1 mapa pago, com caixa e qualidade. Conteúdo e código entram em piloto delimitado; atendimento só após base, escalonamento e limite homologados. A agenda financeira é hipótese de venda e não cronograma garantido; capacidade e aquisição precisam ser contratadas antes de escalar.</a:t>
+              <a:t>Plano proposto. Dias 1–30: conversar com 10 compradores de nichos e 5 contatos de TI; escolher até 3 nichos e uma oferta B2B prioritária. Dias 31–60: preparar até 3 ofertas testáveis e conferir checkout, entrega, segurança e carga da máquina. Dias 61–90: buscar 50 vendas de loja e 1 mapa pago, com margem e qualidade. Conteúdo e código entram em pilotos delimitados. Atendimento só entra após validar base de respostas, escalonamento e limites. Metas dependem de caixa, aquisição e capacidade; não são vendas confirmadas.</a:t>
             </a:r>
           </a:p>
           <a:p/>
@@ -1360,7 +1360,7 @@
           <a:lstStyle/>
           <a:p>
             <a:r>
-              <a:t>AUMI50% em conjunto: Marcos, Luciana e João, divisão interna a definir. Dani50%. Isso não define aportes iguais, cargos, trabalho ou remuneração. Precisamos acordar aportes, chamadas de capital, remuneração, distribuição, propriedade intelectual, veículo, orçamento, impasse e saída. Aprovação conjunta de orçamento e despesas relevantes, com limites formalizados. Retorno da empresa não é devolução automática do capital de Dani.</a:t>
+              <a:t>Proposta, não acordo fechado: 50% AUMI, representada por Marcos, Luciana e João em conjunto, com divisão interna a definir; 50% Dani. Participação não define aporte igual, cargo, rotina, remuneração ou dividendos. Negociar esses pontos e formalizar propriedade intelectual, veículo societário, orçamento, chamadas de capital, impasse e saída. Não atribuímos à Dani todo o capital requerido pelo cenário. A compra depende de aprovação e caixa.</a:t>
             </a:r>
           </a:p>
           <a:p/>
@@ -1442,7 +1442,7 @@
           <a:lstStyle/>
           <a:p>
             <a:r>
-              <a:t>A tese é transformar uma infraestrutura comum em entregas úteis. O cliente compra um resultado delimitado, não uma quantidade abstrata de tokens. Receita depende de oferta, venda, pessoas e qualidade, não apenas da máquina.</a:t>
+              <a:t>Uma empresa não precisa contratar um modelo de IA. Pode contratar as peças da próxima campanha, a automação de uma rotina ou a organização do atendimento. AUMI propõe assumir uma entrega com escopo, revisão e responsável. O Topologic acrescenta mapas para decisões de TI; a loja vende produtos digitais diretamente ao consumidor.</a:t>
             </a:r>
           </a:p>
           <a:p/>
@@ -1524,7 +1524,7 @@
           <a:lstStyle/>
           <a:p>
             <a:r>
-              <a:t>A decisão proposta é avançar para diligência com responsabilidades e limites claros. Validar compradores e números, formalizar a sociedade e aprovar financiamento por marcos. Se o capital disponível for menor que o exigido, redimensionar e recalcular antes de executar. Não há autorização automática de compra, retorno garantido ou contrato já existente.</a:t>
+              <a:t>O convite é definir juntos a primeira oferta a validar, quem fará cada parte e o limite de gasto dessa etapa. Em paralelo, negociar o acordo societário e obter cotação. Cada nova liberação de capital deve se apoiar em resultado verificável: comprador, entrega, margem e capacidade. Não inventamos um valor de piloto que não foi orçado. Menos capital exige escopo menor e novo fluxo financeiro, não promessa de executar a base com caixa insuficiente.</a:t>
             </a:r>
           </a:p>
           <a:p/>
@@ -2344,7 +2344,7 @@
           <a:lstStyle/>
           <a:p>
             <a:r>
-              <a:t>Não usamos uma estatística inventada. Estes são problemas que queremos verificar com compradores e na própria operação: pesquisa sem contexto compartilhado, produção repetitiva e revisão tardia. O custo deve ser medido em horas, retrabalho e contribuição, antes de prometer economia.</a:t>
+              <a:t>Estas são situações de compra que vamos investigar, não dores medidas em uma pesquisa própria. O briefing ainda precisa virar material utilizável. Um script precisa funcionar no processo do cliente. Uma resposta precisa respeitar a política da empresa. Nosso argumento é assumir esse trabalho, com responsabilidade e limites claros.</a:t>
             </a:r>
           </a:p>
           <a:p/>
@@ -3246,7 +3246,7 @@
           <a:lstStyle/>
           <a:p>
             <a:r>
-              <a:t>O desenho é proposto. Fontes entram com autorização e limites. Os agentes usam contexto e ferramentas, mas a revisão humana continua responsável pela qualidade e pela liberação. Publicação, contrato e pagamento não ficam livres para automação.</a:t>
+              <a:t>O fluxo proposto começa no material e no objetivo do cliente. Agentes preparam rascunhos, consultam fontes e executam tarefas delimitadas. Uma pessoa confere qualidade, testes e exceções. O cliente recebe uma entrega acordada, não uma saída bruta do modelo. Isso ainda precisa ser implantado e validado por oferta.</a:t>
             </a:r>
           </a:p>
           <a:p/>
@@ -3328,7 +3328,7 @@
           <a:lstStyle/>
           <a:p>
             <a:r>
-              <a:t>As linhas compartilham infraestrutura e gestão, mas não o mesmo comprador. Não presumimos que o comprador de um infoproduto vira cliente de TI. Todas as ofertas são propostas para validação. A venda de inferência genérica não é o único negócio.</a:t>
+              <a:t>Conteúdo, código e atendimento são serviços para empresas. A loja LATAM é um canal de produtos próprios. Topologic atende compradores de TI. Cada frente tem comprador, aquisição e escopo próprios; compartilhar tecnologia não elimina essa diferença. O lançamento será progressivo, não cinco operações simultâneas.</a:t>
             </a:r>
           </a:p>
           <a:p/>
@@ -3410,7 +3410,7 @@
           <a:lstStyle/>
           <a:p>
             <a:r>
-              <a:t>Estes exemplos são diagramas de entregas propostas, não produtos lançados nem dados de clientes. O conteúdo nasce de um briefing e passa por revisão. O código processa um fluxo autorizado e para em exceções. O atendimento consulta uma fonte e escalona quando não tem certeza. Nenhum exemplo representa benchmark.</a:t>
+              <a:t>Exemplos ilustrativos, não produtos prontos nem clientes reais. Um briefing pode virar roteiro e peças. Uma automação pode validar e transformar dados de entrada, separando exceções. Uma resposta de atendimento pode consultar uma política aprovada e encaminhar dúvidas a uma pessoa. Alcance, erro zero e atendimento ilimitado não são prometidos.</a:t>
             </a:r>
           </a:p>
           <a:p/>
@@ -3492,7 +3492,7 @@
           <a:lstStyle/>
           <a:p>
             <a:r>
-              <a:t>A loja significa infoprodutos para LATAM, vendidos em USD. Espanhol é hipótese inicial de idioma. Vários nichos, escolhidos por validação. Começar com até três, usando dor verificável, disposição de pagar, utilidade demonstrável e baixo risco regulatório. A plataforma é existente, com Hotmart como candidata; não construir marketplace próprio. CAC significa custo para adquirir um pedido e é cobrado em todas as vendas na simulação.</a:t>
+              <a:t>A loja LATAM propõe vender PDFs práticos, templates, kits e minicursos em USD. Diferente de um serviço sob encomenda, um produto pode ser vendido a mais compradores; cada venda continua tendo aquisição, plataforma, tributos e suporte. Espanhol é hipótese inicial. Até três nichos serão escolhidos por dor verificável, disposição de pagar e baixo risco regulatório. Hotmart é candidata de plataforma existente. Não há catálogo pronto ou nicho definido.</a:t>
             </a:r>
           </a:p>
           <a:p/>
@@ -3574,7 +3574,7 @@
           <a:lstStyle/>
           <a:p>
             <a:r>
-              <a:t>Topologic relaciona fontes, sistemas e responsáveis. O mapa inicial custa R$30 mil como preço proposto, com 80 horas diretas e 2 a 4 semanas após contrato e acesso. Limite: um domínio, até 40 componentes e 80 relações, duas fontes documentais ou exportações autorizadas e duas sessões de validação. Entregas: inventário, mapa 2D/3D, dependências, lacunas, PDF executivo e exportação. Inferência não é fato. Não inclui pentest, conector produtivo automático, mudança em sistemas ou economia garantida. Topologic empresarial, R$200 mil mais R$12 mil mensais, é expansão separada, não somada à projeção.</a:t>
+              <a:t>Topologic propõe organizar fontes, sistemas e responsáveis em um mapa. Um comprador de TI pode usar esse material para discutir dependências antes de uma mudança. A oferta inicial proposta é R$30 mil, 80 horas diretas, 2 a 4 semanas após contrato e acesso: um domínio, até 40 componentes e 80 relações, duas fontes autorizadas e duas validações. Entrega inventário, mapa 2D/3D, lacunas, PDF executivo e exportação. Inferência fica identificada. Não inclui pentest, mudança produtiva ou economia garantida. Oferta empresarial de R$200 mil mais R$12 mil mensais é separada e não entra nesta projeção.</a:t>
             </a:r>
           </a:p>
           <a:p/>
@@ -3656,7 +3656,7 @@
           <a:lstStyle/>
           <a:p>
             <a:r>
-              <a:t>Preços de teste, não pesquisa de preço nem contratos assinados. Conteúdo: R$4.500 por mês por 12 peças e 4 roteiros, uma rodada de revisão; vídeo final e mídia avançada à parte. Código: R$18 mil por fluxo delimitado, até 40h diretas. Atendimento: R$6 mil setup mais R$3.500 mensais, com limites a homologar. Loja: ticket hipotético USD29. Mapa: R$30 mil. As horas diretas, tributos, comercial e meios entram nos custos variáveis; o fixo é contado uma vez.</a:t>
+              <a:t>Hipóteses de preço, não contratos assinados. Código: R$18 mil por fluxo delimitado, até 40h. Mapa: R$30 mil. Conteúdo: R$4.500/mês por 12 peças e 4 roteiros, uma revisão e 12h; vídeo final e mídia avançada à parte. Atendimento: R$6 mil de setup e R$3.500/mês com 8h de revisão/suporte; limites de uso a homologar. Loja: ticket USD29. Recorrência depende de retenção; o modelo não aplica churn ao atendimento.</a:t>
             </a:r>
           </a:p>
           <a:p/>
@@ -6863,7 +6863,7 @@
         <p:spPr>
           <a:xfrm>
             <a:off x="571500" y="472440"/>
-            <a:ext cx="4190999" cy="457200"/>
+            <a:ext cx="7239000" cy="457200"/>
           </a:xfrm>
           <a:prstGeom prst="rect">
             <a:avLst/>
@@ -6894,7 +6894,7 @@
                 </a:solidFill>
                 <a:latin typeface="IBM Plex Sans"/>
               </a:rPr>
-              <a:t>aumi / INFRAESTRUTURA PRODUTIVA</a:t>
+              <a:t>aumi / PROPOSTA DE NEGÓCIO PARA DANI</a:t>
             </a:r>
           </a:p>
         </p:txBody>
@@ -6908,82 +6908,82 @@
         <p:spPr>
           <a:xfrm>
             <a:off x="548640" y="1424940"/>
-            <a:ext cx="7543800" cy="3314700"/>
-          </a:xfrm>
-          <a:prstGeom prst="rect">
-            <a:avLst/>
-          </a:prstGeom>
-          <a:noFill/>
-        </p:spPr>
-        <p:txBody>
-          <a:bodyPr wrap="square" lIns="0" rIns="0" tIns="0" bIns="0">
-            <a:spAutoFit/>
-          </a:bodyPr>
-          <a:lstStyle/>
-          <a:p>
-            <a:pPr>
-              <a:lnSpc>
-                <a:spcPct val="112000"/>
-              </a:lnSpc>
-              <a:spcBef>
-                <a:spcPts val="0"/>
-              </a:spcBef>
-              <a:spcAft>
-                <a:spcPts val="0"/>
-              </a:spcAft>
-            </a:pPr>
-            <a:r>
-              <a:rPr sz="6959" b="1">
+            <a:ext cx="7391400" cy="3314700"/>
+          </a:xfrm>
+          <a:prstGeom prst="rect">
+            <a:avLst/>
+          </a:prstGeom>
+          <a:noFill/>
+        </p:spPr>
+        <p:txBody>
+          <a:bodyPr wrap="square" lIns="0" rIns="0" tIns="0" bIns="0">
+            <a:spAutoFit/>
+          </a:bodyPr>
+          <a:lstStyle/>
+          <a:p>
+            <a:pPr>
+              <a:lnSpc>
+                <a:spcPct val="112000"/>
+              </a:lnSpc>
+              <a:spcBef>
+                <a:spcPts val="0"/>
+              </a:spcBef>
+              <a:spcAft>
+                <a:spcPts val="0"/>
+              </a:spcAft>
+            </a:pPr>
+            <a:r>
+              <a:rPr sz="5220" b="1">
                 <a:solidFill>
                   <a:srgbClr val="FFFFFF"/>
                 </a:solidFill>
                 <a:latin typeface="IBM Plex Sans"/>
               </a:rPr>
-              <a:t>PRODUZIR.</a:t>
-            </a:r>
-          </a:p>
-          <a:p>
-            <a:pPr>
-              <a:lnSpc>
-                <a:spcPct val="112000"/>
-              </a:lnSpc>
-              <a:spcBef>
-                <a:spcPts val="0"/>
-              </a:spcBef>
-              <a:spcAft>
-                <a:spcPts val="0"/>
-              </a:spcAft>
-            </a:pPr>
-            <a:r>
-              <a:rPr sz="6959" b="1">
+              <a:t>Uma operação</a:t>
+            </a:r>
+          </a:p>
+          <a:p>
+            <a:pPr>
+              <a:lnSpc>
+                <a:spcPct val="112000"/>
+              </a:lnSpc>
+              <a:spcBef>
+                <a:spcPts val="0"/>
+              </a:spcBef>
+              <a:spcAft>
+                <a:spcPts val="0"/>
+              </a:spcAft>
+            </a:pPr>
+            <a:r>
+              <a:rPr sz="5220" b="1">
                 <a:solidFill>
                   <a:srgbClr val="FFFFFF"/>
                 </a:solidFill>
                 <a:latin typeface="IBM Plex Sans"/>
               </a:rPr>
-              <a:t>ENTREGAR.</a:t>
-            </a:r>
-          </a:p>
-          <a:p>
-            <a:pPr>
-              <a:lnSpc>
-                <a:spcPct val="112000"/>
-              </a:lnSpc>
-              <a:spcBef>
-                <a:spcPts val="0"/>
-              </a:spcBef>
-              <a:spcAft>
-                <a:spcPts val="0"/>
-              </a:spcAft>
-            </a:pPr>
-            <a:r>
-              <a:rPr sz="6959" b="1">
+              <a:t>de IA para</a:t>
+            </a:r>
+          </a:p>
+          <a:p>
+            <a:pPr>
+              <a:lnSpc>
+                <a:spcPct val="112000"/>
+              </a:lnSpc>
+              <a:spcBef>
+                <a:spcPts val="0"/>
+              </a:spcBef>
+              <a:spcAft>
+                <a:spcPts val="0"/>
+              </a:spcAft>
+            </a:pPr>
+            <a:r>
+              <a:rPr sz="5220" b="1">
                 <a:solidFill>
                   <a:srgbClr val="FFFFFF"/>
                 </a:solidFill>
                 <a:latin typeface="IBM Plex Sans"/>
               </a:rPr>
-              <a:t>ESCALAR.</a:t>
+              <a:t>vender pela AUMI.</a:t>
             </a:r>
           </a:p>
         </p:txBody>
@@ -7022,35 +7022,35 @@
               </a:spcAft>
             </a:pPr>
             <a:r>
-              <a:rPr sz="2820" b="1">
+              <a:rPr sz="2580" b="1">
                 <a:solidFill>
                   <a:srgbClr val="FF7B22"/>
                 </a:solidFill>
                 <a:latin typeface="IBM Plex Sans"/>
               </a:rPr>
-              <a:t>Inteligência que trabalha</a:t>
-            </a:r>
-          </a:p>
-          <a:p>
-            <a:pPr>
-              <a:lnSpc>
-                <a:spcPct val="112000"/>
-              </a:lnSpc>
-              <a:spcBef>
-                <a:spcPts val="0"/>
-              </a:spcBef>
-              <a:spcAft>
-                <a:spcPts val="0"/>
-              </a:spcAft>
-            </a:pPr>
-            <a:r>
-              <a:rPr sz="2820" b="1">
+              <a:t>Serviços para empresas.</a:t>
+            </a:r>
+          </a:p>
+          <a:p>
+            <a:pPr>
+              <a:lnSpc>
+                <a:spcPct val="112000"/>
+              </a:lnSpc>
+              <a:spcBef>
+                <a:spcPts val="0"/>
+              </a:spcBef>
+              <a:spcAft>
+                <a:spcPts val="0"/>
+              </a:spcAft>
+            </a:pPr>
+            <a:r>
+              <a:rPr sz="2580" b="1">
                 <a:solidFill>
                   <a:srgbClr val="FF7B22"/>
                 </a:solidFill>
                 <a:latin typeface="IBM Plex Sans"/>
               </a:rPr>
-              <a:t>para a AUMI.</a:t>
+              <a:t>Produtos digitais próprios.</a:t>
             </a:r>
           </a:p>
         </p:txBody>
@@ -7063,39 +7063,39 @@
         </p:nvSpPr>
         <p:spPr>
           <a:xfrm>
-            <a:off x="8458200" y="2560320"/>
-            <a:ext cx="2286000" cy="381000"/>
-          </a:xfrm>
-          <a:prstGeom prst="rect">
-            <a:avLst/>
-          </a:prstGeom>
-          <a:noFill/>
-        </p:spPr>
-        <p:txBody>
-          <a:bodyPr wrap="square" lIns="0" rIns="0" tIns="0" bIns="0">
-            <a:spAutoFit/>
-          </a:bodyPr>
-          <a:lstStyle/>
-          <a:p>
-            <a:pPr>
-              <a:lnSpc>
-                <a:spcPct val="112000"/>
-              </a:lnSpc>
-              <a:spcBef>
-                <a:spcPts val="0"/>
-              </a:spcBef>
-              <a:spcAft>
-                <a:spcPts val="0"/>
-              </a:spcAft>
-            </a:pPr>
-            <a:r>
-              <a:rPr sz="2039" b="1">
+            <a:off x="8305800" y="2560320"/>
+            <a:ext cx="2590800" cy="381000"/>
+          </a:xfrm>
+          <a:prstGeom prst="rect">
+            <a:avLst/>
+          </a:prstGeom>
+          <a:noFill/>
+        </p:spPr>
+        <p:txBody>
+          <a:bodyPr wrap="square" lIns="0" rIns="0" tIns="0" bIns="0">
+            <a:spAutoFit/>
+          </a:bodyPr>
+          <a:lstStyle/>
+          <a:p>
+            <a:pPr>
+              <a:lnSpc>
+                <a:spcPct val="112000"/>
+              </a:lnSpc>
+              <a:spcBef>
+                <a:spcPts val="0"/>
+              </a:spcBef>
+              <a:spcAft>
+                <a:spcPts val="0"/>
+              </a:spcAft>
+            </a:pPr>
+            <a:r>
+              <a:rPr sz="1920" b="1">
                 <a:solidFill>
                   <a:srgbClr val="35105C"/>
                 </a:solidFill>
                 <a:latin typeface="IBM Plex Sans"/>
               </a:rPr>
-              <a:t>CRIAR</a:t>
+              <a:t>SERVIÇOS</a:t>
             </a:r>
           </a:p>
         </p:txBody>
@@ -7108,39 +7108,39 @@
         </p:nvSpPr>
         <p:spPr>
           <a:xfrm>
-            <a:off x="8991600" y="3581400"/>
-            <a:ext cx="1943100" cy="381000"/>
-          </a:xfrm>
-          <a:prstGeom prst="rect">
-            <a:avLst/>
-          </a:prstGeom>
-          <a:noFill/>
-        </p:spPr>
-        <p:txBody>
-          <a:bodyPr wrap="square" lIns="0" rIns="0" tIns="0" bIns="0">
-            <a:spAutoFit/>
-          </a:bodyPr>
-          <a:lstStyle/>
-          <a:p>
-            <a:pPr>
-              <a:lnSpc>
-                <a:spcPct val="112000"/>
-              </a:lnSpc>
-              <a:spcBef>
-                <a:spcPts val="0"/>
-              </a:spcBef>
-              <a:spcAft>
-                <a:spcPts val="0"/>
-              </a:spcAft>
-            </a:pPr>
-            <a:r>
-              <a:rPr sz="2039" b="1">
+            <a:off x="8763000" y="3581400"/>
+            <a:ext cx="2209800" cy="381000"/>
+          </a:xfrm>
+          <a:prstGeom prst="rect">
+            <a:avLst/>
+          </a:prstGeom>
+          <a:noFill/>
+        </p:spPr>
+        <p:txBody>
+          <a:bodyPr wrap="square" lIns="0" rIns="0" tIns="0" bIns="0">
+            <a:spAutoFit/>
+          </a:bodyPr>
+          <a:lstStyle/>
+          <a:p>
+            <a:pPr>
+              <a:lnSpc>
+                <a:spcPct val="112000"/>
+              </a:lnSpc>
+              <a:spcBef>
+                <a:spcPts val="0"/>
+              </a:spcBef>
+              <a:spcAft>
+                <a:spcPts val="0"/>
+              </a:spcAft>
+            </a:pPr>
+            <a:r>
+              <a:rPr sz="1920" b="1">
                 <a:solidFill>
                   <a:srgbClr val="35105C"/>
                 </a:solidFill>
                 <a:latin typeface="IBM Plex Sans"/>
               </a:rPr>
-              <a:t>OPERAR</a:t>
+              <a:t>PRODUTOS</a:t>
             </a:r>
           </a:p>
         </p:txBody>
@@ -7154,38 +7154,38 @@
         <p:spPr>
           <a:xfrm>
             <a:off x="8305800" y="4617720"/>
-            <a:ext cx="2438400" cy="381000"/>
-          </a:xfrm>
-          <a:prstGeom prst="rect">
-            <a:avLst/>
-          </a:prstGeom>
-          <a:noFill/>
-        </p:spPr>
-        <p:txBody>
-          <a:bodyPr wrap="square" lIns="0" rIns="0" tIns="0" bIns="0">
-            <a:spAutoFit/>
-          </a:bodyPr>
-          <a:lstStyle/>
-          <a:p>
-            <a:pPr>
-              <a:lnSpc>
-                <a:spcPct val="112000"/>
-              </a:lnSpc>
-              <a:spcBef>
-                <a:spcPts val="0"/>
-              </a:spcBef>
-              <a:spcAft>
-                <a:spcPts val="0"/>
-              </a:spcAft>
-            </a:pPr>
-            <a:r>
-              <a:rPr sz="2039" b="1">
+            <a:ext cx="2590800" cy="381000"/>
+          </a:xfrm>
+          <a:prstGeom prst="rect">
+            <a:avLst/>
+          </a:prstGeom>
+          <a:noFill/>
+        </p:spPr>
+        <p:txBody>
+          <a:bodyPr wrap="square" lIns="0" rIns="0" tIns="0" bIns="0">
+            <a:spAutoFit/>
+          </a:bodyPr>
+          <a:lstStyle/>
+          <a:p>
+            <a:pPr>
+              <a:lnSpc>
+                <a:spcPct val="112000"/>
+              </a:lnSpc>
+              <a:spcBef>
+                <a:spcPts val="0"/>
+              </a:spcBef>
+              <a:spcAft>
+                <a:spcPts val="0"/>
+              </a:spcAft>
+            </a:pPr>
+            <a:r>
+              <a:rPr sz="1920" b="1">
                 <a:solidFill>
                   <a:srgbClr val="FFFFFF"/>
                 </a:solidFill>
                 <a:latin typeface="IBM Plex Sans"/>
               </a:rPr>
-              <a:t>EVOLUIR</a:t>
+              <a:t>IA PRÓPRIA</a:t>
             </a:r>
           </a:p>
         </p:txBody>
@@ -7582,7 +7582,7 @@
                 </a:solidFill>
                 <a:latin typeface="IBM Plex Sans"/>
               </a:rPr>
-              <a:t>09 / ARQUITETURA PROPOSTA</a:t>
+              <a:t>09 / O PAPEL DA DGX</a:t>
             </a:r>
           </a:p>
         </p:txBody>
@@ -7672,7 +7672,7 @@
                 </a:solidFill>
                 <a:latin typeface="IBM Plex Sans"/>
               </a:rPr>
-              <a:t>Uma DGX desde o início.</a:t>
+              <a:t>Por que uma máquina própria?</a:t>
             </a:r>
           </a:p>
           <a:p>
@@ -7694,7 +7694,7 @@
                 </a:solidFill>
                 <a:latin typeface="IBM Plex Sans"/>
               </a:rPr>
-              <a:t>Uma infraestrutura para toda a AUMI.</a:t>
+              <a:t>Para trabalhar em várias entregas.</a:t>
             </a:r>
           </a:p>
         </p:txBody>
@@ -7739,7 +7739,7 @@
                 </a:solidFill>
                 <a:latin typeface="IBM Plex Sans"/>
               </a:rPr>
-              <a:t>ENTRADAS</a:t>
+              <a:t>TRABALHO</a:t>
             </a:r>
           </a:p>
         </p:txBody>
@@ -7784,7 +7784,7 @@
                 </a:solidFill>
                 <a:latin typeface="IBM Plex Sans"/>
               </a:rPr>
-              <a:t>Equipe e ferramentas</a:t>
+              <a:t>Briefings e documentos</a:t>
             </a:r>
           </a:p>
           <a:p>
@@ -7806,7 +7806,7 @@
                 </a:solidFill>
                 <a:latin typeface="IBM Plex Sans"/>
               </a:rPr>
-              <a:t>Autenticação</a:t>
+              <a:t>Código e testes</a:t>
             </a:r>
           </a:p>
           <a:p>
@@ -7828,7 +7828,7 @@
                 </a:solidFill>
                 <a:latin typeface="IBM Plex Sans"/>
               </a:rPr>
-              <a:t>Isolamento por cliente</a:t>
+              <a:t>Políticas de atendimento</a:t>
             </a:r>
           </a:p>
           <a:p>
@@ -7850,7 +7850,7 @@
                 </a:solidFill>
                 <a:latin typeface="IBM Plex Sans"/>
               </a:rPr>
-              <a:t>Fontes autorizadas</a:t>
+              <a:t>Fontes de TI</a:t>
             </a:r>
           </a:p>
         </p:txBody>
@@ -7895,7 +7895,7 @@
                 </a:solidFill>
                 <a:latin typeface="IBM Plex Sans"/>
               </a:rPr>
-              <a:t>1 × DGX SPARK</a:t>
+              <a:t>BASE COMPARTILHADA</a:t>
             </a:r>
           </a:p>
         </p:txBody>
@@ -7940,7 +7940,7 @@
                 </a:solidFill>
                 <a:latin typeface="IBM Plex Sans"/>
               </a:rPr>
-              <a:t>128 GB • 4 TB • GB10</a:t>
+              <a:t>1 DGX Spark • 128 GB • 4 TB</a:t>
             </a:r>
           </a:p>
           <a:p>
@@ -7962,7 +7962,7 @@
                 </a:solidFill>
                 <a:latin typeface="IBM Plex Sans"/>
               </a:rPr>
-              <a:t>Fila e produção agendada</a:t>
+              <a:t>Modelos locais com vLLM ou SGLang</a:t>
             </a:r>
           </a:p>
           <a:p>
@@ -7984,7 +7984,7 @@
                 </a:solidFill>
                 <a:latin typeface="IBM Plex Sans"/>
               </a:rPr>
-              <a:t>vLLM OU SGLang</a:t>
+              <a:t>Fila por prioridade</a:t>
             </a:r>
           </a:p>
           <a:p>
@@ -8006,7 +8006,7 @@
                 </a:solidFill>
                 <a:latin typeface="IBM Plex Sans"/>
               </a:rPr>
-              <a:t>Modelos e cargas a homologar</a:t>
+              <a:t>Contexto separado por cliente</a:t>
             </a:r>
           </a:p>
         </p:txBody>
@@ -8051,7 +8051,7 @@
                 </a:solidFill>
                 <a:latin typeface="IBM Plex Sans"/>
               </a:rPr>
-              <a:t>FORA DA DGX</a:t>
+              <a:t>COMPLEMENTOS</a:t>
             </a:r>
           </a:p>
         </p:txBody>
@@ -8096,7 +8096,7 @@
                 </a:solidFill>
                 <a:latin typeface="IBM Plex Sans"/>
               </a:rPr>
-              <a:t>Cloud / aplicação</a:t>
+              <a:t>Pessoas e revisão</a:t>
             </a:r>
           </a:p>
           <a:p>
@@ -8118,7 +8118,7 @@
                 </a:solidFill>
                 <a:latin typeface="IBM Plex Sans"/>
               </a:rPr>
-              <a:t>Checkout e downloads</a:t>
+              <a:t>Aplicação / checkout</a:t>
             </a:r>
           </a:p>
           <a:p>
@@ -8140,29 +8140,29 @@
                 </a:solidFill>
                 <a:latin typeface="IBM Plex Sans"/>
               </a:rPr>
+              <a:t>Cloud quando necessário</a:t>
+            </a:r>
+          </a:p>
+          <a:p>
+            <a:pPr>
+              <a:lnSpc>
+                <a:spcPct val="112000"/>
+              </a:lnSpc>
+              <a:spcBef>
+                <a:spcPts val="0"/>
+              </a:spcBef>
+              <a:spcAft>
+                <a:spcPts val="0"/>
+              </a:spcAft>
+            </a:pPr>
+            <a:r>
+              <a:rPr sz="1620" b="0">
+                <a:solidFill>
+                  <a:srgbClr val="29143D"/>
+                </a:solidFill>
+                <a:latin typeface="IBM Plex Sans"/>
+              </a:rPr>
               <a:t>Backup separado</a:t>
-            </a:r>
-          </a:p>
-          <a:p>
-            <a:pPr>
-              <a:lnSpc>
-                <a:spcPct val="112000"/>
-              </a:lnSpc>
-              <a:spcBef>
-                <a:spcPts val="0"/>
-              </a:spcBef>
-              <a:spcAft>
-                <a:spcPts val="0"/>
-              </a:spcAft>
-            </a:pPr>
-            <a:r>
-              <a:rPr sz="1620" b="0">
-                <a:solidFill>
-                  <a:srgbClr val="29143D"/>
-                </a:solidFill>
-                <a:latin typeface="IBM Plex Sans"/>
-              </a:rPr>
-              <a:t>Revisão humana</a:t>
             </a:r>
           </a:p>
         </p:txBody>
@@ -8207,7 +8207,7 @@
                 </a:solidFill>
                 <a:latin typeface="IBM Plex Sans"/>
               </a:rPr>
-              <a:t>Imagem, áudio e vídeo: pipelines específicos. Sem throughput ou SLA prometido.</a:t>
+              <a:t>A compra precisa se justificar frente às APIs. Capacidade e economia serão medidas.</a:t>
             </a:r>
           </a:p>
         </p:txBody>
@@ -8489,7 +8489,7 @@
                 </a:solidFill>
                 <a:latin typeface="IBM Plex Sans"/>
               </a:rPr>
-              <a:t>10 / CAPACIDADE E CONTROLE</a:t>
+              <a:t>10 / COMO EVITAR SOBRECARGA</a:t>
             </a:r>
           </a:p>
         </p:txBody>
@@ -8534,7 +8534,7 @@
                 </a:solidFill>
                 <a:latin typeface="IBM Plex Sans"/>
               </a:rPr>
-              <a:t>A mesma GPU.</a:t>
+              <a:t>Organizar a produção</a:t>
             </a:r>
           </a:p>
           <a:p>
@@ -8556,7 +8556,7 @@
                 </a:solidFill>
                 <a:latin typeface="IBM Plex Sans"/>
               </a:rPr>
-              <a:t>A mesma equipe.</a:t>
+              <a:t>antes de prometer</a:t>
             </a:r>
           </a:p>
           <a:p>
@@ -8578,7 +8578,7 @@
                 </a:solidFill>
                 <a:latin typeface="IBM Plex Sans"/>
               </a:rPr>
-              <a:t>Uma fila com prioridades.</a:t>
+              <a:t>mais entregas.</a:t>
             </a:r>
           </a:p>
         </p:txBody>
@@ -8668,7 +8668,7 @@
                 </a:solidFill>
                 <a:latin typeface="IBM Plex Sans"/>
               </a:rPr>
-              <a:t>Homologar modelo + carga + qualidade.</a:t>
+              <a:t>Medir custo e tempo por entrega.</a:t>
             </a:r>
           </a:p>
           <a:p>
@@ -8690,7 +8690,7 @@
                 </a:solidFill>
                 <a:latin typeface="IBM Plex Sans"/>
               </a:rPr>
-              <a:t>Medir tempo humano e margem.</a:t>
+              <a:t>Definir limites por contrato.</a:t>
             </a:r>
           </a:p>
           <a:p>
@@ -8712,7 +8712,7 @@
                 </a:solidFill>
                 <a:latin typeface="IBM Plex Sans"/>
               </a:rPr>
-              <a:t>Só depois assumir compromisso.</a:t>
+              <a:t>Expandir quando houver demanda.</a:t>
             </a:r>
           </a:p>
         </p:txBody>
@@ -8757,7 +8757,7 @@
                 </a:solidFill>
                 <a:latin typeface="IBM Plex Sans"/>
               </a:rPr>
-              <a:t>01 / PRIORITÁRIO</a:t>
+              <a:t>RESPOSTAS</a:t>
             </a:r>
           </a:p>
         </p:txBody>
@@ -8802,7 +8802,7 @@
                 </a:solidFill>
                 <a:latin typeface="IBM Plex Sans"/>
               </a:rPr>
-              <a:t>Atendimento com limites</a:t>
+              <a:t>Prioridade para atendimento</a:t>
             </a:r>
           </a:p>
         </p:txBody>
@@ -8847,7 +8847,7 @@
                 </a:solidFill>
                 <a:latin typeface="IBM Plex Sans"/>
               </a:rPr>
-              <a:t>02 / AGENDADO</a:t>
+              <a:t>PRODUÇÃO</a:t>
             </a:r>
           </a:p>
         </p:txBody>
@@ -8892,7 +8892,7 @@
                 </a:solidFill>
                 <a:latin typeface="IBM Plex Sans"/>
               </a:rPr>
-              <a:t>Produção de conteúdo e código</a:t>
+              <a:t>Agendar conteúdo e código</a:t>
             </a:r>
           </a:p>
         </p:txBody>
@@ -8937,7 +8937,7 @@
                 </a:solidFill>
                 <a:latin typeface="IBM Plex Sans"/>
               </a:rPr>
-              <a:t>03 / CONTROLADO</a:t>
+              <a:t>DESENVOLVIMENTO</a:t>
             </a:r>
           </a:p>
         </p:txBody>
@@ -8982,7 +8982,7 @@
                 </a:solidFill>
                 <a:latin typeface="IBM Plex Sans"/>
               </a:rPr>
-              <a:t>P&amp;D, mapas e testes de modelos</a:t>
+              <a:t>Reservar espaço para mapas e P&amp;D</a:t>
             </a:r>
           </a:p>
         </p:txBody>
@@ -9027,7 +9027,7 @@
                 </a:solidFill>
                 <a:latin typeface="IBM Plex Sans"/>
               </a:rPr>
-              <a:t>Nova máquina só com utilização e receita justificadas. Sem capacidade duplicada.</a:t>
+              <a:t>Mais contratos exigem capacidade de pessoas e máquina, não só espaço na fila.</a:t>
             </a:r>
           </a:p>
         </p:txBody>
@@ -9183,23 +9183,581 @@
         <p:nvPr/>
       </p:nvGrpSpPr>
       <p:grpSpPr/>
+      <p:sp>
+        <p:nvSpPr>
+          <p:cNvPr id="2" name="Rectangle 1"/>
+          <p:cNvSpPr/>
+          <p:nvPr/>
+        </p:nvSpPr>
+        <p:spPr>
+          <a:xfrm>
+            <a:off x="579120" y="2628900"/>
+            <a:ext cx="5372100" cy="2689860"/>
+          </a:xfrm>
+          <a:prstGeom prst="rect">
+            <a:avLst/>
+          </a:prstGeom>
+          <a:solidFill>
+            <a:srgbClr val="EEE7F5"/>
+          </a:solidFill>
+          <a:ln>
+            <a:noFill/>
+          </a:ln>
+        </p:spPr>
+        <p:style>
+          <a:lnRef idx="1">
+            <a:schemeClr val="accent1"/>
+          </a:lnRef>
+          <a:fillRef idx="3">
+            <a:schemeClr val="accent1"/>
+          </a:fillRef>
+          <a:effectRef idx="2">
+            <a:schemeClr val="accent1"/>
+          </a:effectRef>
+          <a:fontRef idx="minor">
+            <a:schemeClr val="lt1"/>
+          </a:fontRef>
+        </p:style>
+        <p:txBody>
+          <a:bodyPr rtlCol="0" anchor="ctr"/>
+          <a:lstStyle/>
+          <a:p>
+            <a:pPr algn="ctr"/>
+          </a:p>
+        </p:txBody>
+      </p:sp>
+      <p:sp>
+        <p:nvSpPr>
+          <p:cNvPr id="3" name="Rectangle 2"/>
+          <p:cNvSpPr/>
+          <p:nvPr/>
+        </p:nvSpPr>
+        <p:spPr>
+          <a:xfrm>
+            <a:off x="6225540" y="2628900"/>
+            <a:ext cx="5372100" cy="2689860"/>
+          </a:xfrm>
+          <a:prstGeom prst="rect">
+            <a:avLst/>
+          </a:prstGeom>
+          <a:solidFill>
+            <a:srgbClr val="EEE7F5"/>
+          </a:solidFill>
+          <a:ln>
+            <a:noFill/>
+          </a:ln>
+        </p:spPr>
+        <p:style>
+          <a:lnRef idx="1">
+            <a:schemeClr val="accent1"/>
+          </a:lnRef>
+          <a:fillRef idx="3">
+            <a:schemeClr val="accent1"/>
+          </a:fillRef>
+          <a:effectRef idx="2">
+            <a:schemeClr val="accent1"/>
+          </a:effectRef>
+          <a:fontRef idx="minor">
+            <a:schemeClr val="lt1"/>
+          </a:fontRef>
+        </p:style>
+        <p:txBody>
+          <a:bodyPr rtlCol="0" anchor="ctr"/>
+          <a:lstStyle/>
+          <a:p>
+            <a:pPr algn="ctr"/>
+          </a:p>
+        </p:txBody>
+      </p:sp>
+      <p:sp>
+        <p:nvSpPr>
+          <p:cNvPr id="4" name="TextBox 3"/>
+          <p:cNvSpPr txBox="1"/>
+          <p:nvPr/>
+        </p:nvSpPr>
+        <p:spPr>
+          <a:xfrm>
+            <a:off x="548640" y="358140"/>
+            <a:ext cx="9525000" cy="266700"/>
+          </a:xfrm>
+          <a:prstGeom prst="rect">
+            <a:avLst/>
+          </a:prstGeom>
+          <a:noFill/>
+        </p:spPr>
+        <p:txBody>
+          <a:bodyPr wrap="square" lIns="0" rIns="0" tIns="0" bIns="0">
+            <a:spAutoFit/>
+          </a:bodyPr>
+          <a:lstStyle/>
+          <a:p>
+            <a:pPr>
+              <a:lnSpc>
+                <a:spcPct val="112000"/>
+              </a:lnSpc>
+              <a:spcBef>
+                <a:spcPts val="0"/>
+              </a:spcBef>
+              <a:spcAft>
+                <a:spcPts val="0"/>
+              </a:spcAft>
+            </a:pPr>
+            <a:r>
+              <a:rPr sz="1260" b="1">
+                <a:solidFill>
+                  <a:srgbClr val="35105C"/>
+                </a:solidFill>
+                <a:latin typeface="IBM Plex Sans"/>
+              </a:rPr>
+              <a:t>11 / NOSSA PROPOSTA DE DIFERENCIAÇÃO</a:t>
+            </a:r>
+          </a:p>
+        </p:txBody>
+      </p:sp>
+      <p:sp>
+        <p:nvSpPr>
+          <p:cNvPr id="5" name="TextBox 4"/>
+          <p:cNvSpPr txBox="1"/>
+          <p:nvPr/>
+        </p:nvSpPr>
+        <p:spPr>
+          <a:xfrm>
+            <a:off x="10439400" y="320040"/>
+            <a:ext cx="1219200" cy="365760"/>
+          </a:xfrm>
+          <a:prstGeom prst="rect">
+            <a:avLst/>
+          </a:prstGeom>
+          <a:noFill/>
+        </p:spPr>
+        <p:txBody>
+          <a:bodyPr wrap="square" lIns="0" rIns="0" tIns="0" bIns="0">
+            <a:spAutoFit/>
+          </a:bodyPr>
+          <a:lstStyle/>
+          <a:p>
+            <a:pPr>
+              <a:lnSpc>
+                <a:spcPct val="112000"/>
+              </a:lnSpc>
+              <a:spcBef>
+                <a:spcPts val="0"/>
+              </a:spcBef>
+              <a:spcAft>
+                <a:spcPts val="0"/>
+              </a:spcAft>
+            </a:pPr>
+            <a:r>
+              <a:rPr sz="2160" b="1">
+                <a:solidFill>
+                  <a:srgbClr val="35105C"/>
+                </a:solidFill>
+                <a:latin typeface="IBM Plex Sans"/>
+              </a:rPr>
+              <a:t>aumi</a:t>
+            </a:r>
+          </a:p>
+        </p:txBody>
+      </p:sp>
+      <p:sp>
+        <p:nvSpPr>
+          <p:cNvPr id="6" name="TextBox 5"/>
+          <p:cNvSpPr txBox="1"/>
+          <p:nvPr/>
+        </p:nvSpPr>
+        <p:spPr>
+          <a:xfrm>
+            <a:off x="548640" y="906780"/>
+            <a:ext cx="11049000" cy="1325880"/>
+          </a:xfrm>
+          <a:prstGeom prst="rect">
+            <a:avLst/>
+          </a:prstGeom>
+          <a:noFill/>
+        </p:spPr>
+        <p:txBody>
+          <a:bodyPr wrap="square" lIns="0" rIns="0" tIns="0" bIns="0">
+            <a:spAutoFit/>
+          </a:bodyPr>
+          <a:lstStyle/>
+          <a:p>
+            <a:pPr>
+              <a:lnSpc>
+                <a:spcPct val="112000"/>
+              </a:lnSpc>
+              <a:spcBef>
+                <a:spcPts val="0"/>
+              </a:spcBef>
+              <a:spcAft>
+                <a:spcPts val="0"/>
+              </a:spcAft>
+            </a:pPr>
+            <a:r>
+              <a:rPr sz="4079" b="1">
+                <a:solidFill>
+                  <a:srgbClr val="29143D"/>
+                </a:solidFill>
+                <a:latin typeface="IBM Plex Sans"/>
+              </a:rPr>
+              <a:t>Por que contratar a AUMI</a:t>
+            </a:r>
+          </a:p>
+          <a:p>
+            <a:pPr>
+              <a:lnSpc>
+                <a:spcPct val="112000"/>
+              </a:lnSpc>
+              <a:spcBef>
+                <a:spcPts val="0"/>
+              </a:spcBef>
+              <a:spcAft>
+                <a:spcPts val="0"/>
+              </a:spcAft>
+            </a:pPr>
+            <a:r>
+              <a:rPr sz="4079" b="1">
+                <a:solidFill>
+                  <a:srgbClr val="29143D"/>
+                </a:solidFill>
+                <a:latin typeface="IBM Plex Sans"/>
+              </a:rPr>
+              <a:t>se já existem ferramentas?</a:t>
+            </a:r>
+          </a:p>
+        </p:txBody>
+      </p:sp>
+      <p:sp>
+        <p:nvSpPr>
+          <p:cNvPr id="7" name="TextBox 6"/>
+          <p:cNvSpPr txBox="1"/>
+          <p:nvPr/>
+        </p:nvSpPr>
+        <p:spPr>
+          <a:xfrm>
+            <a:off x="777240" y="2796540"/>
+            <a:ext cx="4975860" cy="350520"/>
+          </a:xfrm>
+          <a:prstGeom prst="rect">
+            <a:avLst/>
+          </a:prstGeom>
+          <a:noFill/>
+        </p:spPr>
+        <p:txBody>
+          <a:bodyPr wrap="square" lIns="0" rIns="0" tIns="0" bIns="0">
+            <a:spAutoFit/>
+          </a:bodyPr>
+          <a:lstStyle/>
+          <a:p>
+            <a:pPr>
+              <a:lnSpc>
+                <a:spcPct val="112000"/>
+              </a:lnSpc>
+              <a:spcBef>
+                <a:spcPts val="0"/>
+              </a:spcBef>
+              <a:spcAft>
+                <a:spcPts val="0"/>
+              </a:spcAft>
+            </a:pPr>
+            <a:r>
+              <a:rPr sz="1739" b="1">
+                <a:solidFill>
+                  <a:srgbClr val="9A3D00"/>
+                </a:solidFill>
+                <a:latin typeface="IBM Plex Sans"/>
+              </a:rPr>
+              <a:t>ALTERNATIVA</a:t>
+            </a:r>
+          </a:p>
+        </p:txBody>
+      </p:sp>
+      <p:sp>
+        <p:nvSpPr>
+          <p:cNvPr id="8" name="TextBox 7"/>
+          <p:cNvSpPr txBox="1"/>
+          <p:nvPr/>
+        </p:nvSpPr>
+        <p:spPr>
+          <a:xfrm>
+            <a:off x="777240" y="3253740"/>
+            <a:ext cx="4975860" cy="723900"/>
+          </a:xfrm>
+          <a:prstGeom prst="rect">
+            <a:avLst/>
+          </a:prstGeom>
+          <a:noFill/>
+        </p:spPr>
+        <p:txBody>
+          <a:bodyPr wrap="square" lIns="0" rIns="0" tIns="0" bIns="0">
+            <a:spAutoFit/>
+          </a:bodyPr>
+          <a:lstStyle/>
+          <a:p>
+            <a:pPr>
+              <a:lnSpc>
+                <a:spcPct val="112000"/>
+              </a:lnSpc>
+              <a:spcBef>
+                <a:spcPts val="0"/>
+              </a:spcBef>
+              <a:spcAft>
+                <a:spcPts val="0"/>
+              </a:spcAft>
+            </a:pPr>
+            <a:r>
+              <a:rPr sz="2280" b="1">
+                <a:solidFill>
+                  <a:srgbClr val="29143D"/>
+                </a:solidFill>
+                <a:latin typeface="IBM Plex Sans"/>
+              </a:rPr>
+              <a:t>Comprar uma ferramenta</a:t>
+            </a:r>
+          </a:p>
+        </p:txBody>
+      </p:sp>
+      <p:sp>
+        <p:nvSpPr>
+          <p:cNvPr id="9" name="TextBox 8"/>
+          <p:cNvSpPr txBox="1"/>
+          <p:nvPr/>
+        </p:nvSpPr>
+        <p:spPr>
+          <a:xfrm>
+            <a:off x="777240" y="4053840"/>
+            <a:ext cx="4975860" cy="1188720"/>
+          </a:xfrm>
+          <a:prstGeom prst="rect">
+            <a:avLst/>
+          </a:prstGeom>
+          <a:noFill/>
+        </p:spPr>
+        <p:txBody>
+          <a:bodyPr wrap="square" lIns="0" rIns="0" tIns="0" bIns="0">
+            <a:spAutoFit/>
+          </a:bodyPr>
+          <a:lstStyle/>
+          <a:p>
+            <a:pPr>
+              <a:lnSpc>
+                <a:spcPct val="112000"/>
+              </a:lnSpc>
+              <a:spcBef>
+                <a:spcPts val="0"/>
+              </a:spcBef>
+              <a:spcAft>
+                <a:spcPts val="0"/>
+              </a:spcAft>
+            </a:pPr>
+            <a:r>
+              <a:rPr sz="1859" b="0">
+                <a:solidFill>
+                  <a:srgbClr val="29143D"/>
+                </a:solidFill>
+                <a:latin typeface="IBM Plex Sans"/>
+              </a:rPr>
+              <a:t>A equipe do cliente ainda precisa configurar, produzir, conferir e manter o processo.</a:t>
+            </a:r>
+          </a:p>
+        </p:txBody>
+      </p:sp>
+      <p:sp>
+        <p:nvSpPr>
+          <p:cNvPr id="10" name="TextBox 9"/>
+          <p:cNvSpPr txBox="1"/>
+          <p:nvPr/>
+        </p:nvSpPr>
+        <p:spPr>
+          <a:xfrm>
+            <a:off x="6423660" y="2796540"/>
+            <a:ext cx="4975860" cy="350520"/>
+          </a:xfrm>
+          <a:prstGeom prst="rect">
+            <a:avLst/>
+          </a:prstGeom>
+          <a:noFill/>
+        </p:spPr>
+        <p:txBody>
+          <a:bodyPr wrap="square" lIns="0" rIns="0" tIns="0" bIns="0">
+            <a:spAutoFit/>
+          </a:bodyPr>
+          <a:lstStyle/>
+          <a:p>
+            <a:pPr>
+              <a:lnSpc>
+                <a:spcPct val="112000"/>
+              </a:lnSpc>
+              <a:spcBef>
+                <a:spcPts val="0"/>
+              </a:spcBef>
+              <a:spcAft>
+                <a:spcPts val="0"/>
+              </a:spcAft>
+            </a:pPr>
+            <a:r>
+              <a:rPr sz="1739" b="1">
+                <a:solidFill>
+                  <a:srgbClr val="9A3D00"/>
+                </a:solidFill>
+                <a:latin typeface="IBM Plex Sans"/>
+              </a:rPr>
+              <a:t>NOSSA OFERTA</a:t>
+            </a:r>
+          </a:p>
+        </p:txBody>
+      </p:sp>
+      <p:sp>
+        <p:nvSpPr>
+          <p:cNvPr id="11" name="TextBox 10"/>
+          <p:cNvSpPr txBox="1"/>
+          <p:nvPr/>
+        </p:nvSpPr>
+        <p:spPr>
+          <a:xfrm>
+            <a:off x="6423660" y="3253740"/>
+            <a:ext cx="4975860" cy="723900"/>
+          </a:xfrm>
+          <a:prstGeom prst="rect">
+            <a:avLst/>
+          </a:prstGeom>
+          <a:noFill/>
+        </p:spPr>
+        <p:txBody>
+          <a:bodyPr wrap="square" lIns="0" rIns="0" tIns="0" bIns="0">
+            <a:spAutoFit/>
+          </a:bodyPr>
+          <a:lstStyle/>
+          <a:p>
+            <a:pPr>
+              <a:lnSpc>
+                <a:spcPct val="112000"/>
+              </a:lnSpc>
+              <a:spcBef>
+                <a:spcPts val="0"/>
+              </a:spcBef>
+              <a:spcAft>
+                <a:spcPts val="0"/>
+              </a:spcAft>
+            </a:pPr>
+            <a:r>
+              <a:rPr sz="2280" b="1">
+                <a:solidFill>
+                  <a:srgbClr val="29143D"/>
+                </a:solidFill>
+                <a:latin typeface="IBM Plex Sans"/>
+              </a:rPr>
+              <a:t>Contratar uma entrega</a:t>
+            </a:r>
+          </a:p>
+        </p:txBody>
+      </p:sp>
+      <p:sp>
+        <p:nvSpPr>
+          <p:cNvPr id="12" name="TextBox 11"/>
+          <p:cNvSpPr txBox="1"/>
+          <p:nvPr/>
+        </p:nvSpPr>
+        <p:spPr>
+          <a:xfrm>
+            <a:off x="6423660" y="4053840"/>
+            <a:ext cx="4975860" cy="1188720"/>
+          </a:xfrm>
+          <a:prstGeom prst="rect">
+            <a:avLst/>
+          </a:prstGeom>
+          <a:noFill/>
+        </p:spPr>
+        <p:txBody>
+          <a:bodyPr wrap="square" lIns="0" rIns="0" tIns="0" bIns="0">
+            <a:spAutoFit/>
+          </a:bodyPr>
+          <a:lstStyle/>
+          <a:p>
+            <a:pPr>
+              <a:lnSpc>
+                <a:spcPct val="112000"/>
+              </a:lnSpc>
+              <a:spcBef>
+                <a:spcPts val="0"/>
+              </a:spcBef>
+              <a:spcAft>
+                <a:spcPts val="0"/>
+              </a:spcAft>
+            </a:pPr>
+            <a:r>
+              <a:rPr sz="1859" b="0">
+                <a:solidFill>
+                  <a:srgbClr val="29143D"/>
+                </a:solidFill>
+                <a:latin typeface="IBM Plex Sans"/>
+              </a:rPr>
+              <a:t>A AUMI propõe assumir um escopo, usar o contexto do cliente e responder pela revisão.</a:t>
+            </a:r>
+          </a:p>
+        </p:txBody>
+      </p:sp>
+      <p:sp>
+        <p:nvSpPr>
+          <p:cNvPr id="13" name="TextBox 12"/>
+          <p:cNvSpPr txBox="1"/>
+          <p:nvPr/>
+        </p:nvSpPr>
+        <p:spPr>
+          <a:xfrm>
+            <a:off x="579120" y="5821680"/>
+            <a:ext cx="11003280" cy="525780"/>
+          </a:xfrm>
+          <a:prstGeom prst="rect">
+            <a:avLst/>
+          </a:prstGeom>
+          <a:noFill/>
+        </p:spPr>
+        <p:txBody>
+          <a:bodyPr wrap="square" lIns="0" rIns="0" tIns="0" bIns="0">
+            <a:spAutoFit/>
+          </a:bodyPr>
+          <a:lstStyle/>
+          <a:p>
+            <a:pPr>
+              <a:lnSpc>
+                <a:spcPct val="112000"/>
+              </a:lnSpc>
+              <a:spcBef>
+                <a:spcPts val="0"/>
+              </a:spcBef>
+              <a:spcAft>
+                <a:spcPts val="0"/>
+              </a:spcAft>
+            </a:pPr>
+            <a:r>
+              <a:rPr sz="1800" b="1">
+                <a:solidFill>
+                  <a:srgbClr val="35105C"/>
+                </a:solidFill>
+                <a:latin typeface="IBM Plex Sans"/>
+              </a:rPr>
+              <a:t>A prova comercial será um piloto pago, com critério de aceite combinado.</a:t>
+            </a:r>
+          </a:p>
+        </p:txBody>
+      </p:sp>
       <p:cxnSp>
         <p:nvCxnSpPr>
-          <p:cNvPr id="2" name="Connector 1"/>
+          <p:cNvPr id="14" name="Connector 13"/>
           <p:cNvCxnSpPr/>
           <p:nvPr/>
         </p:nvCxnSpPr>
         <p:spPr>
           <a:xfrm>
-            <a:off x="6096000" y="2667000"/>
-            <a:ext cx="0" cy="2933700"/>
+            <a:off x="548640" y="6316980"/>
+            <a:ext cx="11094720" cy="0"/>
           </a:xfrm>
           <a:prstGeom prst="line">
             <a:avLst/>
           </a:prstGeom>
-          <a:ln w="22859">
+          <a:ln w="7620">
             <a:solidFill>
-              <a:srgbClr val="EEE7F5"/>
+              <a:srgbClr val="D8C9E7"/>
             </a:solidFill>
           </a:ln>
         </p:spPr>
@@ -9220,602 +9778,7 @@
       </p:cxnSp>
       <p:sp>
         <p:nvSpPr>
-          <p:cNvPr id="3" name="TextBox 2"/>
-          <p:cNvSpPr txBox="1"/>
-          <p:nvPr/>
-        </p:nvSpPr>
-        <p:spPr>
-          <a:xfrm>
-            <a:off x="548640" y="358140"/>
-            <a:ext cx="9525000" cy="266700"/>
-          </a:xfrm>
-          <a:prstGeom prst="rect">
-            <a:avLst/>
-          </a:prstGeom>
-          <a:noFill/>
-        </p:spPr>
-        <p:txBody>
-          <a:bodyPr wrap="square" lIns="0" rIns="0" tIns="0" bIns="0">
-            <a:spAutoFit/>
-          </a:bodyPr>
-          <a:lstStyle/>
-          <a:p>
-            <a:pPr>
-              <a:lnSpc>
-                <a:spcPct val="112000"/>
-              </a:lnSpc>
-              <a:spcBef>
-                <a:spcPts val="0"/>
-              </a:spcBef>
-              <a:spcAft>
-                <a:spcPts val="0"/>
-              </a:spcAft>
-            </a:pPr>
-            <a:r>
-              <a:rPr sz="1260" b="1">
-                <a:solidFill>
-                  <a:srgbClr val="35105C"/>
-                </a:solidFill>
-                <a:latin typeface="IBM Plex Sans"/>
-              </a:rPr>
-              <a:t>11 / EVIDÊNCIA E CONCORRÊNCIA</a:t>
-            </a:r>
-          </a:p>
-        </p:txBody>
-      </p:sp>
-      <p:sp>
-        <p:nvSpPr>
-          <p:cNvPr id="4" name="TextBox 3"/>
-          <p:cNvSpPr txBox="1"/>
-          <p:nvPr/>
-        </p:nvSpPr>
-        <p:spPr>
-          <a:xfrm>
-            <a:off x="10439400" y="320040"/>
-            <a:ext cx="1219200" cy="365760"/>
-          </a:xfrm>
-          <a:prstGeom prst="rect">
-            <a:avLst/>
-          </a:prstGeom>
-          <a:noFill/>
-        </p:spPr>
-        <p:txBody>
-          <a:bodyPr wrap="square" lIns="0" rIns="0" tIns="0" bIns="0">
-            <a:spAutoFit/>
-          </a:bodyPr>
-          <a:lstStyle/>
-          <a:p>
-            <a:pPr>
-              <a:lnSpc>
-                <a:spcPct val="112000"/>
-              </a:lnSpc>
-              <a:spcBef>
-                <a:spcPts val="0"/>
-              </a:spcBef>
-              <a:spcAft>
-                <a:spcPts val="0"/>
-              </a:spcAft>
-            </a:pPr>
-            <a:r>
-              <a:rPr sz="2160" b="1">
-                <a:solidFill>
-                  <a:srgbClr val="35105C"/>
-                </a:solidFill>
-                <a:latin typeface="IBM Plex Sans"/>
-              </a:rPr>
-              <a:t>aumi</a:t>
-            </a:r>
-          </a:p>
-        </p:txBody>
-      </p:sp>
-      <p:sp>
-        <p:nvSpPr>
-          <p:cNvPr id="5" name="TextBox 4"/>
-          <p:cNvSpPr txBox="1"/>
-          <p:nvPr/>
-        </p:nvSpPr>
-        <p:spPr>
-          <a:xfrm>
-            <a:off x="548640" y="906780"/>
-            <a:ext cx="11049000" cy="1325880"/>
-          </a:xfrm>
-          <a:prstGeom prst="rect">
-            <a:avLst/>
-          </a:prstGeom>
-          <a:noFill/>
-        </p:spPr>
-        <p:txBody>
-          <a:bodyPr wrap="square" lIns="0" rIns="0" tIns="0" bIns="0">
-            <a:spAutoFit/>
-          </a:bodyPr>
-          <a:lstStyle/>
-          <a:p>
-            <a:pPr>
-              <a:lnSpc>
-                <a:spcPct val="112000"/>
-              </a:lnSpc>
-              <a:spcBef>
-                <a:spcPts val="0"/>
-              </a:spcBef>
-              <a:spcAft>
-                <a:spcPts val="0"/>
-              </a:spcAft>
-            </a:pPr>
-            <a:r>
-              <a:rPr sz="4079" b="1">
-                <a:solidFill>
-                  <a:srgbClr val="29143D"/>
-                </a:solidFill>
-                <a:latin typeface="IBM Plex Sans"/>
-              </a:rPr>
-              <a:t>Há sinais de mercado.</a:t>
-            </a:r>
-          </a:p>
-          <a:p>
-            <a:pPr>
-              <a:lnSpc>
-                <a:spcPct val="112000"/>
-              </a:lnSpc>
-              <a:spcBef>
-                <a:spcPts val="0"/>
-              </a:spcBef>
-              <a:spcAft>
-                <a:spcPts val="0"/>
-              </a:spcAft>
-            </a:pPr>
-            <a:r>
-              <a:rPr sz="4079" b="1">
-                <a:solidFill>
-                  <a:srgbClr val="29143D"/>
-                </a:solidFill>
-                <a:latin typeface="IBM Plex Sans"/>
-              </a:rPr>
-              <a:t>A nossa venda ainda precisa ser provada.</a:t>
-            </a:r>
-          </a:p>
-        </p:txBody>
-      </p:sp>
-      <p:sp>
-        <p:nvSpPr>
-          <p:cNvPr id="6" name="TextBox 5"/>
-          <p:cNvSpPr txBox="1"/>
-          <p:nvPr/>
-        </p:nvSpPr>
-        <p:spPr>
-          <a:xfrm>
-            <a:off x="586740" y="2644140"/>
-            <a:ext cx="5067300" cy="701040"/>
-          </a:xfrm>
-          <a:prstGeom prst="rect">
-            <a:avLst/>
-          </a:prstGeom>
-          <a:noFill/>
-        </p:spPr>
-        <p:txBody>
-          <a:bodyPr wrap="square" lIns="0" rIns="0" tIns="0" bIns="0">
-            <a:spAutoFit/>
-          </a:bodyPr>
-          <a:lstStyle/>
-          <a:p>
-            <a:pPr>
-              <a:lnSpc>
-                <a:spcPct val="112000"/>
-              </a:lnSpc>
-              <a:spcBef>
-                <a:spcPts val="0"/>
-              </a:spcBef>
-              <a:spcAft>
-                <a:spcPts val="0"/>
-              </a:spcAft>
-            </a:pPr>
-            <a:r>
-              <a:rPr sz="4200" b="1">
-                <a:solidFill>
-                  <a:srgbClr val="35105C"/>
-                </a:solidFill>
-                <a:latin typeface="IBM Plex Sans"/>
-              </a:rPr>
-              <a:t>21 milhões</a:t>
-            </a:r>
-          </a:p>
-        </p:txBody>
-      </p:sp>
-      <p:sp>
-        <p:nvSpPr>
-          <p:cNvPr id="7" name="TextBox 6"/>
-          <p:cNvSpPr txBox="1"/>
-          <p:nvPr/>
-        </p:nvSpPr>
-        <p:spPr>
-          <a:xfrm>
-            <a:off x="586740" y="3467100"/>
-            <a:ext cx="5067300" cy="914400"/>
-          </a:xfrm>
-          <a:prstGeom prst="rect">
-            <a:avLst/>
-          </a:prstGeom>
-          <a:noFill/>
-        </p:spPr>
-        <p:txBody>
-          <a:bodyPr wrap="square" lIns="0" rIns="0" tIns="0" bIns="0">
-            <a:spAutoFit/>
-          </a:bodyPr>
-          <a:lstStyle/>
-          <a:p>
-            <a:pPr>
-              <a:lnSpc>
-                <a:spcPct val="112000"/>
-              </a:lnSpc>
-              <a:spcBef>
-                <a:spcPts val="0"/>
-              </a:spcBef>
-              <a:spcAft>
-                <a:spcPts val="0"/>
-              </a:spcAft>
-            </a:pPr>
-            <a:r>
-              <a:rPr sz="1859" b="0">
-                <a:solidFill>
-                  <a:srgbClr val="35105C"/>
-                </a:solidFill>
-                <a:latin typeface="IBM Plex Sans"/>
-              </a:rPr>
-              <a:t>Compradores globais Hotmart / Teachable.</a:t>
-            </a:r>
-          </a:p>
-          <a:p>
-            <a:pPr>
-              <a:lnSpc>
-                <a:spcPct val="112000"/>
-              </a:lnSpc>
-              <a:spcBef>
-                <a:spcPts val="0"/>
-              </a:spcBef>
-              <a:spcAft>
-                <a:spcPts val="0"/>
-              </a:spcAft>
-            </a:pPr>
-            <a:r>
-              <a:rPr sz="1859" b="0">
-                <a:solidFill>
-                  <a:srgbClr val="35105C"/>
-                </a:solidFill>
-                <a:latin typeface="IBM Plex Sans"/>
-              </a:rPr>
-              <a:t>Dado autorrelatado; 12 meses até mar/2024.</a:t>
-            </a:r>
-          </a:p>
-        </p:txBody>
-      </p:sp>
-      <p:sp>
-        <p:nvSpPr>
-          <p:cNvPr id="8" name="TextBox 7"/>
-          <p:cNvSpPr txBox="1"/>
-          <p:nvPr/>
-        </p:nvSpPr>
-        <p:spPr>
-          <a:xfrm>
-            <a:off x="6606540" y="2644140"/>
-            <a:ext cx="5013960" cy="701040"/>
-          </a:xfrm>
-          <a:prstGeom prst="rect">
-            <a:avLst/>
-          </a:prstGeom>
-          <a:noFill/>
-        </p:spPr>
-        <p:txBody>
-          <a:bodyPr wrap="square" lIns="0" rIns="0" tIns="0" bIns="0">
-            <a:spAutoFit/>
-          </a:bodyPr>
-          <a:lstStyle/>
-          <a:p>
-            <a:pPr>
-              <a:lnSpc>
-                <a:spcPct val="112000"/>
-              </a:lnSpc>
-              <a:spcBef>
-                <a:spcPts val="0"/>
-              </a:spcBef>
-              <a:spcAft>
-                <a:spcPts val="0"/>
-              </a:spcAft>
-            </a:pPr>
-            <a:r>
-              <a:rPr sz="4200" b="1">
-                <a:solidFill>
-                  <a:srgbClr val="35105C"/>
-                </a:solidFill>
-                <a:latin typeface="IBM Plex Sans"/>
-              </a:rPr>
-              <a:t>84%</a:t>
-            </a:r>
-          </a:p>
-        </p:txBody>
-      </p:sp>
-      <p:sp>
-        <p:nvSpPr>
-          <p:cNvPr id="9" name="TextBox 8"/>
-          <p:cNvSpPr txBox="1"/>
-          <p:nvPr/>
-        </p:nvSpPr>
-        <p:spPr>
-          <a:xfrm>
-            <a:off x="6606540" y="3467100"/>
-            <a:ext cx="5013960" cy="914400"/>
-          </a:xfrm>
-          <a:prstGeom prst="rect">
-            <a:avLst/>
-          </a:prstGeom>
-          <a:noFill/>
-        </p:spPr>
-        <p:txBody>
-          <a:bodyPr wrap="square" lIns="0" rIns="0" tIns="0" bIns="0">
-            <a:spAutoFit/>
-          </a:bodyPr>
-          <a:lstStyle/>
-          <a:p>
-            <a:pPr>
-              <a:lnSpc>
-                <a:spcPct val="112000"/>
-              </a:lnSpc>
-              <a:spcBef>
-                <a:spcPts val="0"/>
-              </a:spcBef>
-              <a:spcAft>
-                <a:spcPts val="0"/>
-              </a:spcAft>
-            </a:pPr>
-            <a:r>
-              <a:rPr sz="1859" b="0">
-                <a:solidFill>
-                  <a:srgbClr val="35105C"/>
-                </a:solidFill>
-                <a:latin typeface="IBM Plex Sans"/>
-              </a:rPr>
-              <a:t>Gestão do gasto cloud como desafio.</a:t>
-            </a:r>
-          </a:p>
-          <a:p>
-            <a:pPr>
-              <a:lnSpc>
-                <a:spcPct val="112000"/>
-              </a:lnSpc>
-              <a:spcBef>
-                <a:spcPts val="0"/>
-              </a:spcBef>
-              <a:spcAft>
-                <a:spcPts val="0"/>
-              </a:spcAft>
-            </a:pPr>
-            <a:r>
-              <a:rPr sz="1859" b="0">
-                <a:solidFill>
-                  <a:srgbClr val="35105C"/>
-                </a:solidFill>
-                <a:latin typeface="IBM Plex Sans"/>
-              </a:rPr>
-              <a:t>Pesquisa global Flexera 2025.</a:t>
-            </a:r>
-          </a:p>
-        </p:txBody>
-      </p:sp>
-      <p:sp>
-        <p:nvSpPr>
-          <p:cNvPr id="10" name="TextBox 9"/>
-          <p:cNvSpPr txBox="1"/>
-          <p:nvPr/>
-        </p:nvSpPr>
-        <p:spPr>
-          <a:xfrm>
-            <a:off x="586740" y="4709160"/>
-            <a:ext cx="5143500" cy="876300"/>
-          </a:xfrm>
-          <a:prstGeom prst="rect">
-            <a:avLst/>
-          </a:prstGeom>
-          <a:noFill/>
-        </p:spPr>
-        <p:txBody>
-          <a:bodyPr wrap="square" lIns="0" rIns="0" tIns="0" bIns="0">
-            <a:spAutoFit/>
-          </a:bodyPr>
-          <a:lstStyle/>
-          <a:p>
-            <a:pPr>
-              <a:lnSpc>
-                <a:spcPct val="112000"/>
-              </a:lnSpc>
-              <a:spcBef>
-                <a:spcPts val="0"/>
-              </a:spcBef>
-              <a:spcAft>
-                <a:spcPts val="0"/>
-              </a:spcAft>
-            </a:pPr>
-            <a:r>
-              <a:rPr sz="1859" b="0">
-                <a:solidFill>
-                  <a:srgbClr val="29143D"/>
-                </a:solidFill>
-                <a:latin typeface="IBM Plex Sans"/>
-              </a:rPr>
-              <a:t>Conteúdo gratuito, criadores,</a:t>
-            </a:r>
-          </a:p>
-          <a:p>
-            <a:pPr>
-              <a:lnSpc>
-                <a:spcPct val="112000"/>
-              </a:lnSpc>
-              <a:spcBef>
-                <a:spcPts val="0"/>
-              </a:spcBef>
-              <a:spcAft>
-                <a:spcPts val="0"/>
-              </a:spcAft>
-            </a:pPr>
-            <a:r>
-              <a:rPr sz="1859" b="0">
-                <a:solidFill>
-                  <a:srgbClr val="29143D"/>
-                </a:solidFill>
-                <a:latin typeface="IBM Plex Sans"/>
-              </a:rPr>
-              <a:t>marketplaces, SaaS e agências.</a:t>
-            </a:r>
-          </a:p>
-        </p:txBody>
-      </p:sp>
-      <p:sp>
-        <p:nvSpPr>
-          <p:cNvPr id="11" name="TextBox 10"/>
-          <p:cNvSpPr txBox="1"/>
-          <p:nvPr/>
-        </p:nvSpPr>
-        <p:spPr>
-          <a:xfrm>
-            <a:off x="6606540" y="4709160"/>
-            <a:ext cx="4953000" cy="876300"/>
-          </a:xfrm>
-          <a:prstGeom prst="rect">
-            <a:avLst/>
-          </a:prstGeom>
-          <a:noFill/>
-        </p:spPr>
-        <p:txBody>
-          <a:bodyPr wrap="square" lIns="0" rIns="0" tIns="0" bIns="0">
-            <a:spAutoFit/>
-          </a:bodyPr>
-          <a:lstStyle/>
-          <a:p>
-            <a:pPr>
-              <a:lnSpc>
-                <a:spcPct val="112000"/>
-              </a:lnSpc>
-              <a:spcBef>
-                <a:spcPts val="0"/>
-              </a:spcBef>
-              <a:spcAft>
-                <a:spcPts val="0"/>
-              </a:spcAft>
-            </a:pPr>
-            <a:r>
-              <a:rPr sz="1859" b="0">
-                <a:solidFill>
-                  <a:srgbClr val="29143D"/>
-                </a:solidFill>
-                <a:latin typeface="IBM Plex Sans"/>
-              </a:rPr>
-              <a:t>Consultorias, draw.io,</a:t>
-            </a:r>
-          </a:p>
-          <a:p>
-            <a:pPr>
-              <a:lnSpc>
-                <a:spcPct val="112000"/>
-              </a:lnSpc>
-              <a:spcBef>
-                <a:spcPts val="0"/>
-              </a:spcBef>
-              <a:spcAft>
-                <a:spcPts val="0"/>
-              </a:spcAft>
-            </a:pPr>
-            <a:r>
-              <a:rPr sz="1859" b="0">
-                <a:solidFill>
-                  <a:srgbClr val="29143D"/>
-                </a:solidFill>
-                <a:latin typeface="IBM Plex Sans"/>
-              </a:rPr>
-              <a:t>LeanIX e ServiceNow.</a:t>
-            </a:r>
-          </a:p>
-        </p:txBody>
-      </p:sp>
-      <p:sp>
-        <p:nvSpPr>
-          <p:cNvPr id="12" name="TextBox 11"/>
-          <p:cNvSpPr txBox="1"/>
-          <p:nvPr/>
-        </p:nvSpPr>
-        <p:spPr>
-          <a:xfrm>
-            <a:off x="579120" y="5829300"/>
-            <a:ext cx="11003280" cy="525780"/>
-          </a:xfrm>
-          <a:prstGeom prst="rect">
-            <a:avLst/>
-          </a:prstGeom>
-          <a:noFill/>
-        </p:spPr>
-        <p:txBody>
-          <a:bodyPr wrap="square" lIns="0" rIns="0" tIns="0" bIns="0">
-            <a:spAutoFit/>
-          </a:bodyPr>
-          <a:lstStyle/>
-          <a:p>
-            <a:pPr>
-              <a:lnSpc>
-                <a:spcPct val="112000"/>
-              </a:lnSpc>
-              <a:spcBef>
-                <a:spcPts val="0"/>
-              </a:spcBef>
-              <a:spcAft>
-                <a:spcPts val="0"/>
-              </a:spcAft>
-            </a:pPr>
-            <a:r>
-              <a:rPr sz="1800" b="1">
-                <a:solidFill>
-                  <a:srgbClr val="35105C"/>
-                </a:solidFill>
-                <a:latin typeface="IBM Plex Sans"/>
-              </a:rPr>
-              <a:t>Hipótese de valor: resultado delimitado, contexto, fonte e revisão humana.</a:t>
-            </a:r>
-          </a:p>
-        </p:txBody>
-      </p:sp>
-      <p:cxnSp>
-        <p:nvCxnSpPr>
-          <p:cNvPr id="13" name="Connector 12"/>
-          <p:cNvCxnSpPr/>
-          <p:nvPr/>
-        </p:nvCxnSpPr>
-        <p:spPr>
-          <a:xfrm>
-            <a:off x="548640" y="6316980"/>
-            <a:ext cx="11094720" cy="0"/>
-          </a:xfrm>
-          <a:prstGeom prst="line">
-            <a:avLst/>
-          </a:prstGeom>
-          <a:ln w="7620">
-            <a:solidFill>
-              <a:srgbClr val="D8C9E7"/>
-            </a:solidFill>
-          </a:ln>
-        </p:spPr>
-        <p:style>
-          <a:lnRef idx="2">
-            <a:schemeClr val="accent1"/>
-          </a:lnRef>
-          <a:fillRef idx="0">
-            <a:schemeClr val="accent1"/>
-          </a:fillRef>
-          <a:effectRef idx="1">
-            <a:schemeClr val="accent1"/>
-          </a:effectRef>
-          <a:fontRef idx="minor">
-            <a:schemeClr val="tx1"/>
-          </a:fontRef>
-        </p:style>
-      </p:cxnSp>
-      <p:sp>
-        <p:nvSpPr>
-          <p:cNvPr id="14" name="TextBox 13"/>
+          <p:cNvPr id="15" name="TextBox 14"/>
           <p:cNvSpPr txBox="1"/>
           <p:nvPr/>
         </p:nvSpPr>
@@ -9853,14 +9816,14 @@
                 </a:solidFill>
                 <a:latin typeface="IBM Plex Sans"/>
               </a:rPr>
-              <a:t>Fontes públicas: Hotmart, 21/03/2024; Flexera, 19/03/2025. Não são demanda validada da AUMI.</a:t>
-            </a:r>
-          </a:p>
-        </p:txBody>
-      </p:sp>
-      <p:sp>
-        <p:nvSpPr>
-          <p:cNvPr id="15" name="TextBox 14"/>
+              <a:t>Proposta para discussão • 02/10/2026 • Sem promessa de retorno</a:t>
+            </a:r>
+          </a:p>
+        </p:txBody>
+      </p:sp>
+      <p:sp>
+        <p:nvSpPr>
+          <p:cNvPr id="16" name="TextBox 15"/>
           <p:cNvSpPr txBox="1"/>
           <p:nvPr/>
         </p:nvSpPr>
@@ -10213,7 +10176,7 @@
                 </a:solidFill>
                 <a:latin typeface="IBM Plex Sans"/>
               </a:rPr>
-              <a:t>12 / COMO OS SÓCIOS ACOMPANHAM</a:t>
+              <a:t>12 / VISIBILIDADE PARA OS SÓCIOS</a:t>
             </a:r>
           </a:p>
         </p:txBody>
@@ -10303,7 +10266,7 @@
                 </a:solidFill>
                 <a:latin typeface="IBM Plex Sans"/>
               </a:rPr>
-              <a:t>Gestão visível.</a:t>
+              <a:t>Dani acompanha o caixa</a:t>
             </a:r>
           </a:p>
           <a:p>
@@ -10325,7 +10288,7 @@
                 </a:solidFill>
                 <a:latin typeface="IBM Plex Sans"/>
               </a:rPr>
-              <a:t>Decisão humana.</a:t>
+              <a:t>e o que cada frente entrega.</a:t>
             </a:r>
           </a:p>
         </p:txBody>
@@ -10370,7 +10333,7 @@
                 </a:solidFill>
                 <a:latin typeface="IBM Plex Sans"/>
               </a:rPr>
-              <a:t>FONTES</a:t>
+              <a:t>VENDAS</a:t>
             </a:r>
           </a:p>
         </p:txBody>
@@ -10415,7 +10378,7 @@
                 </a:solidFill>
                 <a:latin typeface="IBM Plex Sans"/>
               </a:rPr>
-              <a:t>Checkout • banco • anúncios</a:t>
+              <a:t>Quem comprou e quanto pagou.</a:t>
             </a:r>
           </a:p>
           <a:p>
@@ -10437,7 +10400,7 @@
                 </a:solidFill>
                 <a:latin typeface="IBM Plex Sans"/>
               </a:rPr>
-              <a:t>CRM • projetos • horas</a:t>
+              <a:t>Recebimentos e estornos.</a:t>
             </a:r>
           </a:p>
         </p:txBody>
@@ -10482,7 +10445,7 @@
                 </a:solidFill>
                 <a:latin typeface="IBM Plex Sans"/>
               </a:rPr>
-              <a:t>RECONCILIAÇÃO</a:t>
+              <a:t>ENTREGAS</a:t>
             </a:r>
           </a:p>
         </p:txBody>
@@ -10527,7 +10490,7 @@
                 </a:solidFill>
                 <a:latin typeface="IBM Plex Sans"/>
               </a:rPr>
-              <a:t>Receita • estornos • custos</a:t>
+              <a:t>O que foi entregue e aceito.</a:t>
             </a:r>
           </a:p>
           <a:p>
@@ -10549,7 +10512,7 @@
                 </a:solidFill>
                 <a:latin typeface="IBM Plex Sans"/>
               </a:rPr>
-              <a:t>Fonte, regra e alerta</a:t>
+              <a:t>Horas, custos e pendências.</a:t>
             </a:r>
           </a:p>
         </p:txBody>
@@ -10594,7 +10557,7 @@
                 </a:solidFill>
                 <a:latin typeface="IBM Plex Sans"/>
               </a:rPr>
-              <a:t>PAINEL DOS SÓCIOS</a:t>
+              <a:t>CAIXA</a:t>
             </a:r>
           </a:p>
         </p:txBody>
@@ -10639,7 +10602,7 @@
                 </a:solidFill>
                 <a:latin typeface="IBM Plex Sans"/>
               </a:rPr>
-              <a:t>Diário • semanal • mensal</a:t>
+              <a:t>O que entrou e saiu.</a:t>
             </a:r>
           </a:p>
           <a:p>
@@ -10661,7 +10624,7 @@
                 </a:solidFill>
                 <a:latin typeface="IBM Plex Sans"/>
               </a:rPr>
-              <a:t>Caixa e margem por oferta</a:t>
+              <a:t>Margem por oferta e saldo.</a:t>
             </a:r>
           </a:p>
         </p:txBody>
@@ -10700,13 +10663,13 @@
               </a:spcAft>
             </a:pPr>
             <a:r>
-              <a:rPr sz="1920" b="1">
+              <a:rPr sz="1859" b="1">
                 <a:solidFill>
                   <a:srgbClr val="35105C"/>
                 </a:solidFill>
                 <a:latin typeface="IBM Plex Sans"/>
               </a:rPr>
-              <a:t>PESSOAS APROVAM  /  dinheiro • contratos • publicação • compras</a:t>
+              <a:t>Prestação mensal e orçamento conjunto. Agentes não autorizam gastos.</a:t>
             </a:r>
           </a:p>
         </p:txBody>
@@ -11117,7 +11080,7 @@
                 </a:solidFill>
                 <a:latin typeface="IBM Plex Sans"/>
               </a:rPr>
-              <a:t>13 / ECONOMIA DO PORTFÓLIO</a:t>
+              <a:t>13 / CONTRIBUIÇÃO ESTIMADA POR VENDA</a:t>
             </a:r>
           </a:p>
         </p:txBody>
@@ -11207,7 +11170,7 @@
                 </a:solidFill>
                 <a:latin typeface="IBM Plex Sans"/>
               </a:rPr>
-              <a:t>A receita paga entrega e aquisição.</a:t>
+              <a:t>Quanto cada entrega deixa</a:t>
             </a:r>
           </a:p>
           <a:p>
@@ -11229,7 +11192,7 @@
                 </a:solidFill>
                 <a:latin typeface="IBM Plex Sans"/>
               </a:rPr>
-              <a:t>A contribuição paga a estrutura.</a:t>
+              <a:t>para sustentar a operação.</a:t>
             </a:r>
           </a:p>
         </p:txBody>
@@ -11949,7 +11912,7 @@
                 </a:solidFill>
                 <a:latin typeface="IBM Plex Sans"/>
               </a:rPr>
-              <a:t>Antes dos fixos: R$ 37 mil/mês no ano 1; R$ 42 mil/mês no ano 2.</a:t>
+              <a:t>Ainda falta pagar os fixos: R$ 37 mil/mês no ano 1 e R$ 42 mil no ano 2.</a:t>
             </a:r>
           </a:p>
         </p:txBody>
@@ -11994,7 +11957,7 @@
                 </a:solidFill>
                 <a:latin typeface="IBM Plex Sans"/>
               </a:rPr>
-              <a:t>Atendimento: setup contribui R$ 1.000 (20h). Custos completos no apêndice e na planilha.</a:t>
+              <a:t>Setup de atendimento: contribuição de R$ 1.000 (20h). Hipóteses detalhadas na planilha.</a:t>
             </a:r>
           </a:p>
         </p:txBody>
@@ -12190,7 +12153,7 @@
                 </a:solidFill>
                 <a:latin typeface="IBM Plex Sans"/>
               </a:rPr>
-              <a:t>14 / SIMULAÇÃO DE 24 MESES</a:t>
+              <a:t>14 / TRÊS CENÁRIOS DE 24 MESES</a:t>
             </a:r>
           </a:p>
         </p:txBody>
@@ -12280,7 +12243,7 @@
                 </a:solidFill>
                 <a:latin typeface="IBM Plex Sans"/>
               </a:rPr>
-              <a:t>Três agendas de venda.</a:t>
+              <a:t>O prazo de retorno depende</a:t>
             </a:r>
           </a:p>
           <a:p>
@@ -12302,7 +12265,7 @@
                 </a:solidFill>
                 <a:latin typeface="IBM Plex Sans"/>
               </a:rPr>
-              <a:t>Três necessidades de capital.</a:t>
+              <a:t>do ritmo de vendas e dos custos.</a:t>
             </a:r>
           </a:p>
         </p:txBody>
@@ -12566,13 +12529,13 @@
               </a:spcAft>
             </a:pPr>
             <a:r>
-              <a:rPr sz="1739" b="0">
+              <a:rPr sz="1620" b="0">
                 <a:solidFill>
                   <a:srgbClr val="FFFFFF"/>
                 </a:solidFill>
                 <a:latin typeface="IBM Plex Sans"/>
               </a:rPr>
-              <a:t>Fluxo M24: R$ -577,6 mil</a:t>
+              <a:t>Caixa acum. M24: R$ -577,6 mil</a:t>
             </a:r>
           </a:p>
         </p:txBody>
@@ -12836,13 +12799,13 @@
               </a:spcAft>
             </a:pPr>
             <a:r>
-              <a:rPr sz="1739" b="0">
+              <a:rPr sz="1620" b="0">
                 <a:solidFill>
                   <a:srgbClr val="FFFFFF"/>
                 </a:solidFill>
                 <a:latin typeface="IBM Plex Sans"/>
               </a:rPr>
-              <a:t>Fluxo M24: R$ 1.293,6 mil</a:t>
+              <a:t>Caixa acum. M24: R$ 1.293,6 mil</a:t>
             </a:r>
           </a:p>
         </p:txBody>
@@ -13106,13 +13069,13 @@
               </a:spcAft>
             </a:pPr>
             <a:r>
-              <a:rPr sz="1739" b="0">
+              <a:rPr sz="1620" b="0">
                 <a:solidFill>
                   <a:srgbClr val="FFFFFF"/>
                 </a:solidFill>
                 <a:latin typeface="IBM Plex Sans"/>
               </a:rPr>
-              <a:t>Fluxo M24: R$ 3.138,0 mil</a:t>
+              <a:t>Caixa acum. M24: R$ 3.138,0 mil</a:t>
             </a:r>
           </a:p>
         </p:txBody>
@@ -13157,7 +13120,7 @@
                 </a:solidFill>
                 <a:latin typeface="IBM Plex Sans"/>
               </a:rPr>
-              <a:t>Risco: com CAC USD15, a base exige R$ 500 mil e recupera em M21.</a:t>
+              <a:t>Com CAC USD15, a base exige R$ 500 mil e recupera em M21. Vendas projetadas, não contratadas.</a:t>
             </a:r>
           </a:p>
         </p:txBody>
@@ -13396,7 +13359,7 @@
                 </a:solidFill>
                 <a:latin typeface="IBM Plex Sans"/>
               </a:rPr>
-              <a:t>15 / INVESTIMENTO E CAPITAL DE GIRO</a:t>
+              <a:t>15 / PARA ONDE VAI O DINHEIRO</a:t>
             </a:r>
           </a:p>
         </p:txBody>
@@ -13486,7 +13449,7 @@
                 </a:solidFill>
                 <a:latin typeface="IBM Plex Sans"/>
               </a:rPr>
-              <a:t>R$ 100 mil montam a base.</a:t>
+              <a:t>O investimento precisa pagar</a:t>
             </a:r>
           </a:p>
           <a:p>
@@ -13508,7 +13471,7 @@
                 </a:solidFill>
                 <a:latin typeface="IBM Plex Sans"/>
               </a:rPr>
-              <a:t>Não financiam toda a operação.</a:t>
+              <a:t>a estrutura e o começo da operação.</a:t>
             </a:r>
           </a:p>
         </p:txBody>
@@ -13598,7 +13561,7 @@
                 </a:solidFill>
                 <a:latin typeface="IBM Plex Sans"/>
               </a:rPr>
-              <a:t>Equipamento, proteção, rede,</a:t>
+              <a:t>Máquina, proteção, rede,</a:t>
             </a:r>
           </a:p>
           <a:p>
@@ -13710,7 +13673,7 @@
                 </a:solidFill>
                 <a:latin typeface="IBM Plex Sans"/>
               </a:rPr>
-              <a:t>Jurídico e segurança.</a:t>
+              <a:t>Preparação jurídica</a:t>
             </a:r>
           </a:p>
           <a:p>
@@ -13732,7 +13695,7 @@
                 </a:solidFill>
                 <a:latin typeface="IBM Plex Sans"/>
               </a:rPr>
-              <a:t>Preparação antes de operar.</a:t>
+              <a:t>e segurança.</a:t>
             </a:r>
           </a:p>
         </p:txBody>
@@ -13777,7 +13740,7 @@
                 </a:solidFill>
                 <a:latin typeface="IBM Plex Sans"/>
               </a:rPr>
-              <a:t>Cheque R$ 100k / 150k / 200k → sobra R$ 0 / 50k / 100k.</a:t>
+              <a:t>R$ 100 mil cobrem a preparação inicial.</a:t>
             </a:r>
           </a:p>
           <a:p>
@@ -13799,7 +13762,7 @@
                 </a:solidFill>
                 <a:latin typeface="IBM Plex Sans"/>
               </a:rPr>
-              <a:t>Base ampliada: R$ 430 mil de capital total com reserva.</a:t>
+              <a:t>O cenário-base exige R$ 430 mil no total, incluindo giro e reserva.</a:t>
             </a:r>
           </a:p>
         </p:txBody>
@@ -13844,7 +13807,7 @@
                 </a:solidFill>
                 <a:latin typeface="IBM Plex Sans"/>
               </a:rPr>
-              <a:t>Cotação brasileira pendente. Não comprar a máquina com caixa operacional insuficiente.</a:t>
+              <a:t>Com R$ 150 mil / 200 mil, sobram R$ 50 mil / 100 mil após a preparação. Cotação pendente.</a:t>
             </a:r>
           </a:p>
         </p:txBody>
@@ -14126,7 +14089,7 @@
                 </a:solidFill>
                 <a:latin typeface="IBM Plex Sans"/>
               </a:rPr>
-              <a:t>16 / DOIS RETORNOS DIFERENTES</a:t>
+              <a:t>16 / SEPARAR AS DUAS CONTAS</a:t>
             </a:r>
           </a:p>
         </p:txBody>
@@ -14171,7 +14134,7 @@
                 </a:solidFill>
                 <a:latin typeface="IBM Plex Sans"/>
               </a:rPr>
-              <a:t>A máquina precisa provar</a:t>
+              <a:t>Quando o negócio</a:t>
             </a:r>
           </a:p>
           <a:p>
@@ -14193,7 +14156,29 @@
                 </a:solidFill>
                 <a:latin typeface="IBM Plex Sans"/>
               </a:rPr>
-              <a:t>seu benefício incremental.</a:t>
+              <a:t>se paga? E quando</a:t>
+            </a:r>
+          </a:p>
+          <a:p>
+            <a:pPr>
+              <a:lnSpc>
+                <a:spcPct val="112000"/>
+              </a:lnSpc>
+              <a:spcBef>
+                <a:spcPts val="0"/>
+              </a:spcBef>
+              <a:spcAft>
+                <a:spcPts val="0"/>
+              </a:spcAft>
+            </a:pPr>
+            <a:r>
+              <a:rPr sz="3600" b="1">
+                <a:solidFill>
+                  <a:srgbClr val="29143D"/>
+                </a:solidFill>
+                <a:latin typeface="IBM Plex Sans"/>
+              </a:rPr>
+              <a:t>a máquina compensa?</a:t>
             </a:r>
           </a:p>
         </p:txBody>
@@ -14251,8 +14236,8 @@
         </p:nvSpPr>
         <p:spPr>
           <a:xfrm>
-            <a:off x="609600" y="2804160"/>
-            <a:ext cx="5638800" cy="579120"/>
+            <a:off x="609600" y="2971800"/>
+            <a:ext cx="5638800" cy="495299"/>
           </a:xfrm>
           <a:prstGeom prst="rect">
             <a:avLst/>
@@ -14283,7 +14268,7 @@
                 </a:solidFill>
                 <a:latin typeface="IBM Plex Sans"/>
               </a:rPr>
-              <a:t>NEGÓCIO</a:t>
+              <a:t>RETORNO DO NEGÓCIO</a:t>
             </a:r>
           </a:p>
         </p:txBody>
@@ -14296,105 +14281,105 @@
         </p:nvSpPr>
         <p:spPr>
           <a:xfrm>
-            <a:off x="609600" y="3505200"/>
-            <a:ext cx="5646420" cy="1790700"/>
-          </a:xfrm>
-          <a:prstGeom prst="rect">
-            <a:avLst/>
-          </a:prstGeom>
-          <a:noFill/>
-        </p:spPr>
-        <p:txBody>
-          <a:bodyPr wrap="square" lIns="0" rIns="0" tIns="0" bIns="0">
-            <a:spAutoFit/>
-          </a:bodyPr>
-          <a:lstStyle/>
-          <a:p>
-            <a:pPr>
-              <a:lnSpc>
-                <a:spcPct val="112000"/>
-              </a:lnSpc>
-              <a:spcBef>
-                <a:spcPts val="0"/>
-              </a:spcBef>
-              <a:spcAft>
-                <a:spcPts val="0"/>
-              </a:spcAft>
-            </a:pPr>
-            <a:r>
-              <a:rPr sz="2160" b="0">
+            <a:off x="609600" y="3688080"/>
+            <a:ext cx="5646420" cy="1676400"/>
+          </a:xfrm>
+          <a:prstGeom prst="rect">
+            <a:avLst/>
+          </a:prstGeom>
+          <a:noFill/>
+        </p:spPr>
+        <p:txBody>
+          <a:bodyPr wrap="square" lIns="0" rIns="0" tIns="0" bIns="0">
+            <a:spAutoFit/>
+          </a:bodyPr>
+          <a:lstStyle/>
+          <a:p>
+            <a:pPr>
+              <a:lnSpc>
+                <a:spcPct val="112000"/>
+              </a:lnSpc>
+              <a:spcBef>
+                <a:spcPts val="0"/>
+              </a:spcBef>
+              <a:spcAft>
+                <a:spcPts val="0"/>
+              </a:spcAft>
+            </a:pPr>
+            <a:r>
+              <a:rPr sz="2100" b="0">
                 <a:solidFill>
                   <a:srgbClr val="29143D"/>
                 </a:solidFill>
                 <a:latin typeface="IBM Plex Sans"/>
               </a:rPr>
-              <a:t>Vendas − custos − fixos.</a:t>
-            </a:r>
-          </a:p>
-          <a:p>
-            <a:pPr>
-              <a:lnSpc>
-                <a:spcPct val="112000"/>
-              </a:lnSpc>
-              <a:spcBef>
-                <a:spcPts val="0"/>
-              </a:spcBef>
-              <a:spcAft>
-                <a:spcPts val="0"/>
-              </a:spcAft>
-            </a:pPr>
-            <a:r>
-              <a:rPr sz="2160" b="0">
+              <a:t>Recebimentos menos saídas.</a:t>
+            </a:r>
+          </a:p>
+          <a:p>
+            <a:pPr>
+              <a:lnSpc>
+                <a:spcPct val="112000"/>
+              </a:lnSpc>
+              <a:spcBef>
+                <a:spcPts val="0"/>
+              </a:spcBef>
+              <a:spcAft>
+                <a:spcPts val="0"/>
+              </a:spcAft>
+            </a:pPr>
+            <a:r>
+              <a:rPr sz="2100" b="0">
                 <a:solidFill>
                   <a:srgbClr val="29143D"/>
                 </a:solidFill>
                 <a:latin typeface="IBM Plex Sans"/>
               </a:rPr>
-              <a:t>Capital de giro e recebimento.</a:t>
-            </a:r>
-          </a:p>
-          <a:p>
-            <a:pPr>
-              <a:lnSpc>
-                <a:spcPct val="112000"/>
-              </a:lnSpc>
-              <a:spcBef>
-                <a:spcPts val="0"/>
-              </a:spcBef>
-              <a:spcAft>
-                <a:spcPts val="0"/>
-              </a:spcAft>
-            </a:pPr>
-            <a:r>
-              <a:rPr sz="2160" b="0">
+              <a:t>Na base simulada: M14.</a:t>
+            </a:r>
+          </a:p>
+          <a:p>
+            <a:pPr>
+              <a:lnSpc>
+                <a:spcPct val="112000"/>
+              </a:lnSpc>
+              <a:spcBef>
+                <a:spcPts val="0"/>
+              </a:spcBef>
+              <a:spcAft>
+                <a:spcPts val="0"/>
+              </a:spcAft>
+            </a:pPr>
+            <a:r>
+              <a:rPr sz="2100" b="0">
                 <a:solidFill>
                   <a:srgbClr val="29143D"/>
                 </a:solidFill>
                 <a:latin typeface="IBM Plex Sans"/>
               </a:rPr>
-              <a:t>Base simulada: projeto em M14.</a:t>
-            </a:r>
-          </a:p>
-          <a:p>
-            <a:pPr>
-              <a:lnSpc>
-                <a:spcPct val="112000"/>
-              </a:lnSpc>
-              <a:spcBef>
-                <a:spcPts val="0"/>
-              </a:spcBef>
-              <a:spcAft>
-                <a:spcPts val="0"/>
-              </a:spcAft>
-            </a:pPr>
-            <a:r>
-              <a:rPr sz="2160" b="0">
+              <a:t>Depende das vendas, dos custos</a:t>
+            </a:r>
+          </a:p>
+          <a:p>
+            <a:pPr>
+              <a:lnSpc>
+                <a:spcPct val="112000"/>
+              </a:lnSpc>
+              <a:spcBef>
+                <a:spcPts val="0"/>
+              </a:spcBef>
+              <a:spcAft>
+                <a:spcPts val="0"/>
+              </a:spcAft>
+            </a:pPr>
+            <a:r>
+              <a:rPr sz="2100" b="0">
                 <a:solidFill>
                   <a:srgbClr val="29143D"/>
                 </a:solidFill>
                 <a:latin typeface="IBM Plex Sans"/>
               </a:rPr>
-              <a:t>Depende de caixa e vendas.</a:t>
+              <a:t>e do capital para executar.</a:t>
             </a:r>
           </a:p>
         </p:txBody>
@@ -14433,13 +14418,13 @@
               </a:spcAft>
             </a:pPr>
             <a:r>
-              <a:rPr sz="1920" b="1">
+              <a:rPr sz="1800" b="1">
                 <a:solidFill>
                   <a:srgbClr val="FF7B22"/>
                 </a:solidFill>
                 <a:latin typeface="IBM Plex Sans"/>
               </a:rPr>
-              <a:t>EQUIPAMENTO</a:t>
+              <a:t>BENEFÍCIO DA MÁQUINA</a:t>
             </a:r>
           </a:p>
         </p:txBody>
@@ -14551,7 +14536,7 @@
                 </a:solidFill>
                 <a:latin typeface="IBM Plex Sans"/>
               </a:rPr>
-              <a:t>Exemplo de benefício líquido</a:t>
+              <a:t>Exemplo, não previsão.</a:t>
             </a:r>
           </a:p>
           <a:p>
@@ -14573,7 +14558,7 @@
                 </a:solidFill>
                 <a:latin typeface="IBM Plex Sans"/>
               </a:rPr>
-              <a:t>incremental. Medir contra</a:t>
+              <a:t>R$ 5 mil de benefício líquido</a:t>
             </a:r>
           </a:p>
           <a:p>
@@ -14595,7 +14580,7 @@
                 </a:solidFill>
                 <a:latin typeface="IBM Plex Sans"/>
               </a:rPr>
-              <a:t>operar sem compra.</a:t>
+              <a:t>adicional por mês.</a:t>
             </a:r>
           </a:p>
         </p:txBody>
@@ -14640,7 +14625,7 @@
                 </a:solidFill>
                 <a:latin typeface="IBM Plex Sans"/>
               </a:rPr>
-              <a:t>Toda receita não é receita causada pela máquina. Retorno de Dani: indefinido.</a:t>
+              <a:t>A devolução do aporte de Dani dependerá do acordo entre os sócios.</a:t>
             </a:r>
           </a:p>
         </p:txBody>
@@ -14965,7 +14950,7 @@
                 </a:solidFill>
                 <a:latin typeface="IBM Plex Sans"/>
               </a:rPr>
-              <a:t>17 / EXECUÇÃO POR MARCOS</a:t>
+              <a:t>17 / COMO COMEÇAR</a:t>
             </a:r>
           </a:p>
         </p:txBody>
@@ -15055,7 +15040,7 @@
                 </a:solidFill>
                 <a:latin typeface="IBM Plex Sans"/>
               </a:rPr>
-              <a:t>Começar com contratos e testes.</a:t>
+              <a:t>Os primeiros 90 dias servem</a:t>
             </a:r>
           </a:p>
           <a:p>
@@ -15077,7 +15062,7 @@
                 </a:solidFill>
                 <a:latin typeface="IBM Plex Sans"/>
               </a:rPr>
-              <a:t>Abrir frentes conforme a evidência.</a:t>
+              <a:t>para conquistar e entregar a prova.</a:t>
             </a:r>
           </a:p>
         </p:txBody>
@@ -15167,7 +15152,7 @@
                 </a:solidFill>
                 <a:latin typeface="IBM Plex Sans"/>
               </a:rPr>
-              <a:t>Escolher</a:t>
+              <a:t>Ouvir compradores</a:t>
             </a:r>
           </a:p>
         </p:txBody>
@@ -15234,7 +15219,7 @@
                 </a:solidFill>
                 <a:latin typeface="IBM Plex Sans"/>
               </a:rPr>
-              <a:t>Até 3 nichos; uma oferta</a:t>
+              <a:t>Escolher uma oferta B2B</a:t>
             </a:r>
           </a:p>
           <a:p>
@@ -15256,7 +15241,7 @@
                 </a:solidFill>
                 <a:latin typeface="IBM Plex Sans"/>
               </a:rPr>
-              <a:t>B2B prioritária.</a:t>
+              <a:t>e até 3 nichos.</a:t>
             </a:r>
           </a:p>
         </p:txBody>
@@ -15346,7 +15331,7 @@
                 </a:solidFill>
                 <a:latin typeface="IBM Plex Sans"/>
               </a:rPr>
-              <a:t>Demonstrar</a:t>
+              <a:t>Mostrar a entrega</a:t>
             </a:r>
           </a:p>
         </p:txBody>
@@ -15413,7 +15398,7 @@
                 </a:solidFill>
                 <a:latin typeface="IBM Plex Sans"/>
               </a:rPr>
-              <a:t>Checkout, entrega e dados.</a:t>
+              <a:t>Conferir checkout e entrega.</a:t>
             </a:r>
           </a:p>
           <a:p>
@@ -15435,7 +15420,7 @@
                 </a:solidFill>
                 <a:latin typeface="IBM Plex Sans"/>
               </a:rPr>
-              <a:t>Modelo/carga homologados.</a:t>
+              <a:t>Validar a carga da máquina.</a:t>
             </a:r>
           </a:p>
         </p:txBody>
@@ -15525,7 +15510,7 @@
                 </a:solidFill>
                 <a:latin typeface="IBM Plex Sans"/>
               </a:rPr>
-              <a:t>Cobrar e medir</a:t>
+              <a:t>Vender e conferir</a:t>
             </a:r>
           </a:p>
         </p:txBody>
@@ -15570,7 +15555,7 @@
                 </a:solidFill>
                 <a:latin typeface="IBM Plex Sans"/>
               </a:rPr>
-              <a:t>Alvo condicional: 50 vendas</a:t>
+              <a:t>Meta: 50 vendas de loja</a:t>
             </a:r>
           </a:p>
           <a:p>
@@ -15614,7 +15599,7 @@
                 </a:solidFill>
                 <a:latin typeface="IBM Plex Sans"/>
               </a:rPr>
-              <a:t>Margem, caixa e qualidade.</a:t>
+              <a:t>Medir margem e qualidade.</a:t>
             </a:r>
           </a:p>
         </p:txBody>
@@ -15659,7 +15644,7 @@
                 </a:solidFill>
                 <a:latin typeface="IBM Plex Sans"/>
               </a:rPr>
-              <a:t>Atendimento e novas ofertas entram progressivamente. Sem lançar tudo de uma vez.</a:t>
+              <a:t>Metas condicionadas a caixa e execução. Atendimento entra após validação.</a:t>
             </a:r>
           </a:p>
         </p:txBody>
@@ -15890,7 +15875,7 @@
                 </a:solidFill>
                 <a:latin typeface="IBM Plex Sans"/>
               </a:rPr>
-              <a:t>18 / PARTICIPAÇÃO E GOVERNANÇA</a:t>
+              <a:t>18 / A PROPOSTA SOCIETÁRIA</a:t>
             </a:r>
           </a:p>
         </p:txBody>
@@ -15980,7 +15965,7 @@
                 </a:solidFill>
                 <a:latin typeface="IBM Plex Sans"/>
               </a:rPr>
-              <a:t>Sociedade 50/50.</a:t>
+              <a:t>Dani, a proposta é participar</a:t>
             </a:r>
           </a:p>
           <a:p>
@@ -16002,7 +15987,7 @@
                 </a:solidFill>
                 <a:latin typeface="IBM Plex Sans"/>
               </a:rPr>
-              <a:t>Regras antes do aporte.</a:t>
+              <a:t>da sociedade com 50%.</a:t>
             </a:r>
           </a:p>
         </p:txBody>
@@ -16114,7 +16099,7 @@
                 </a:solidFill>
                 <a:latin typeface="IBM Plex Sans"/>
               </a:rPr>
-              <a:t>Divisão interna ainda a definir.</a:t>
+              <a:t>Divisão interna a definir.</a:t>
             </a:r>
           </a:p>
         </p:txBody>
@@ -16204,7 +16189,7 @@
                 </a:solidFill>
                 <a:latin typeface="IBM Plex Sans"/>
               </a:rPr>
-              <a:t>Aporte, função e remuneração</a:t>
+              <a:t>Participação proposta.</a:t>
             </a:r>
           </a:p>
           <a:p>
@@ -16226,7 +16211,7 @@
                 </a:solidFill>
                 <a:latin typeface="IBM Plex Sans"/>
               </a:rPr>
-              <a:t>ainda não acordados.</a:t>
+              <a:t>Aporte e papel a combinar.</a:t>
             </a:r>
           </a:p>
         </p:txBody>
@@ -16271,7 +16256,7 @@
                 </a:solidFill>
                 <a:latin typeface="IBM Plex Sans"/>
               </a:rPr>
-              <a:t>Formalizar capital, remuneração, distribuição e propriedade intelectual.</a:t>
+              <a:t>Antes do aporte: combinar trabalho, remuneração e distribuição.</a:t>
             </a:r>
           </a:p>
           <a:p>
@@ -16293,7 +16278,7 @@
                 </a:solidFill>
                 <a:latin typeface="IBM Plex Sans"/>
               </a:rPr>
-              <a:t>Definir orçamento, limites de aprovação, impasse e saída.</a:t>
+              <a:t>Formalizar orçamento, propriedade intelectual, impasse e saída.</a:t>
             </a:r>
           </a:p>
         </p:txBody>
@@ -16532,7 +16517,7 @@
                 </a:solidFill>
                 <a:latin typeface="IBM Plex Sans"/>
               </a:rPr>
-              <a:t>01 / A PROPOSTA DE VALOR</a:t>
+              <a:t>01 / O QUE O CLIENTE COMPRA</a:t>
             </a:r>
           </a:p>
         </p:txBody>
@@ -16616,57 +16601,57 @@
               </a:spcAft>
             </a:pPr>
             <a:r>
-              <a:rPr sz="5340" b="1">
+              <a:rPr sz="4560" b="1">
                 <a:solidFill>
                   <a:srgbClr val="35105C"/>
                 </a:solidFill>
                 <a:latin typeface="IBM Plex Sans"/>
               </a:rPr>
-              <a:t>Uma base de IA.</a:t>
-            </a:r>
-          </a:p>
-          <a:p>
-            <a:pPr>
-              <a:lnSpc>
-                <a:spcPct val="112000"/>
-              </a:lnSpc>
-              <a:spcBef>
-                <a:spcPts val="0"/>
-              </a:spcBef>
-              <a:spcAft>
-                <a:spcPts val="0"/>
-              </a:spcAft>
-            </a:pPr>
-            <a:r>
-              <a:rPr sz="5340" b="1">
+              <a:t>Conteúdo para publicar.</a:t>
+            </a:r>
+          </a:p>
+          <a:p>
+            <a:pPr>
+              <a:lnSpc>
+                <a:spcPct val="112000"/>
+              </a:lnSpc>
+              <a:spcBef>
+                <a:spcPts val="0"/>
+              </a:spcBef>
+              <a:spcAft>
+                <a:spcPts val="0"/>
+              </a:spcAft>
+            </a:pPr>
+            <a:r>
+              <a:rPr sz="4560" b="1">
                 <a:solidFill>
                   <a:srgbClr val="35105C"/>
                 </a:solidFill>
                 <a:latin typeface="IBM Plex Sans"/>
               </a:rPr>
-              <a:t>Entregas que alguém</a:t>
-            </a:r>
-          </a:p>
-          <a:p>
-            <a:pPr>
-              <a:lnSpc>
-                <a:spcPct val="112000"/>
-              </a:lnSpc>
-              <a:spcBef>
-                <a:spcPts val="0"/>
-              </a:spcBef>
-              <a:spcAft>
-                <a:spcPts val="0"/>
-              </a:spcAft>
-            </a:pPr>
-            <a:r>
-              <a:rPr sz="5340" b="1">
+              <a:t>Software para operar.</a:t>
+            </a:r>
+          </a:p>
+          <a:p>
+            <a:pPr>
+              <a:lnSpc>
+                <a:spcPct val="112000"/>
+              </a:lnSpc>
+              <a:spcBef>
+                <a:spcPts val="0"/>
+              </a:spcBef>
+              <a:spcAft>
+                <a:spcPts val="0"/>
+              </a:spcAft>
+            </a:pPr>
+            <a:r>
+              <a:rPr sz="4560" b="1">
                 <a:solidFill>
                   <a:srgbClr val="35105C"/>
                 </a:solidFill>
                 <a:latin typeface="IBM Plex Sans"/>
               </a:rPr>
-              <a:t>paga para receber.</a:t>
+              <a:t>Respostas com contexto.</a:t>
             </a:r>
           </a:p>
         </p:txBody>
@@ -16705,35 +16690,35 @@
               </a:spcAft>
             </a:pPr>
             <a:r>
-              <a:rPr sz="2460" b="0">
+              <a:rPr sz="2220" b="0">
                 <a:solidFill>
                   <a:srgbClr val="35105C"/>
                 </a:solidFill>
                 <a:latin typeface="IBM Plex Sans"/>
               </a:rPr>
-              <a:t>Conteúdo, software e atendimento.</a:t>
-            </a:r>
-          </a:p>
-          <a:p>
-            <a:pPr>
-              <a:lnSpc>
-                <a:spcPct val="112000"/>
-              </a:lnSpc>
-              <a:spcBef>
-                <a:spcPts val="0"/>
-              </a:spcBef>
-              <a:spcAft>
-                <a:spcPts val="0"/>
-              </a:spcAft>
-            </a:pPr>
-            <a:r>
-              <a:rPr sz="2460" b="0">
+              <a:t>A empresa contrata uma entrega definida.</a:t>
+            </a:r>
+          </a:p>
+          <a:p>
+            <a:pPr>
+              <a:lnSpc>
+                <a:spcPct val="112000"/>
+              </a:lnSpc>
+              <a:spcBef>
+                <a:spcPts val="0"/>
+              </a:spcBef>
+              <a:spcAft>
+                <a:spcPts val="0"/>
+              </a:spcAft>
+            </a:pPr>
+            <a:r>
+              <a:rPr sz="2220" b="0">
                 <a:solidFill>
                   <a:srgbClr val="35105C"/>
                 </a:solidFill>
                 <a:latin typeface="IBM Plex Sans"/>
               </a:rPr>
-              <a:t>Produtos LATAM e inteligência visual de TI.</a:t>
+              <a:t>A AUMI organiza a produção e responde pela revisão.</a:t>
             </a:r>
           </a:p>
         </p:txBody>
@@ -16929,7 +16914,7 @@
                 </a:solidFill>
                 <a:latin typeface="IBM Plex Sans"/>
               </a:rPr>
-              <a:t>19 / A DECISÃO DE AGORA</a:t>
+              <a:t>19 / PRÓXIMO PASSO PROPOSTO</a:t>
             </a:r>
           </a:p>
         </p:txBody>
@@ -17013,57 +16998,35 @@
               </a:spcAft>
             </a:pPr>
             <a:r>
-              <a:rPr sz="4920" b="1">
+              <a:rPr sz="5280" b="1">
                 <a:solidFill>
                   <a:srgbClr val="35105C"/>
                 </a:solidFill>
                 <a:latin typeface="IBM Plex Sans"/>
               </a:rPr>
-              <a:t>VALIDAR.</a:t>
-            </a:r>
-          </a:p>
-          <a:p>
-            <a:pPr>
-              <a:lnSpc>
-                <a:spcPct val="112000"/>
-              </a:lnSpc>
-              <a:spcBef>
-                <a:spcPts val="0"/>
-              </a:spcBef>
-              <a:spcAft>
-                <a:spcPts val="0"/>
-              </a:spcAft>
-            </a:pPr>
-            <a:r>
-              <a:rPr sz="4920" b="1">
+              <a:t>Vamos começar pela</a:t>
+            </a:r>
+          </a:p>
+          <a:p>
+            <a:pPr>
+              <a:lnSpc>
+                <a:spcPct val="112000"/>
+              </a:lnSpc>
+              <a:spcBef>
+                <a:spcPts val="0"/>
+              </a:spcBef>
+              <a:spcAft>
+                <a:spcPts val="0"/>
+              </a:spcAft>
+            </a:pPr>
+            <a:r>
+              <a:rPr sz="5280" b="1">
                 <a:solidFill>
                   <a:srgbClr val="35105C"/>
                 </a:solidFill>
                 <a:latin typeface="IBM Plex Sans"/>
               </a:rPr>
-              <a:t>FORMALIZAR.</a:t>
-            </a:r>
-          </a:p>
-          <a:p>
-            <a:pPr>
-              <a:lnSpc>
-                <a:spcPct val="112000"/>
-              </a:lnSpc>
-              <a:spcBef>
-                <a:spcPts val="0"/>
-              </a:spcBef>
-              <a:spcAft>
-                <a:spcPts val="0"/>
-              </a:spcAft>
-            </a:pPr>
-            <a:r>
-              <a:rPr sz="4920" b="1">
-                <a:solidFill>
-                  <a:srgbClr val="35105C"/>
-                </a:solidFill>
-                <a:latin typeface="IBM Plex Sans"/>
-              </a:rPr>
-              <a:t>FINANCIAR POR MARCOS.</a:t>
+              <a:t>primeira oferta paga.</a:t>
             </a:r>
           </a:p>
         </p:txBody>
@@ -17102,35 +17065,35 @@
               </a:spcAft>
             </a:pPr>
             <a:r>
-              <a:rPr sz="2640" b="0">
+              <a:rPr sz="2340" b="0">
                 <a:solidFill>
                   <a:srgbClr val="35105C"/>
                 </a:solidFill>
                 <a:latin typeface="IBM Plex Sans"/>
               </a:rPr>
-              <a:t>Comprador real. Escopo testado. Números conferidos.</a:t>
-            </a:r>
-          </a:p>
-          <a:p>
-            <a:pPr>
-              <a:lnSpc>
-                <a:spcPct val="112000"/>
-              </a:lnSpc>
-              <a:spcBef>
-                <a:spcPts val="0"/>
-              </a:spcBef>
-              <a:spcAft>
-                <a:spcPts val="0"/>
-              </a:spcAft>
-            </a:pPr>
-            <a:r>
-              <a:rPr sz="2640" b="0">
+              <a:t>Escolher a oferta, o responsável e o limite de gasto.</a:t>
+            </a:r>
+          </a:p>
+          <a:p>
+            <a:pPr>
+              <a:lnSpc>
+                <a:spcPct val="112000"/>
+              </a:lnSpc>
+              <a:spcBef>
+                <a:spcPts val="0"/>
+              </a:spcBef>
+              <a:spcAft>
+                <a:spcPts val="0"/>
+              </a:spcAft>
+            </a:pPr>
+            <a:r>
+              <a:rPr sz="2340" b="0">
                 <a:solidFill>
                   <a:srgbClr val="35105C"/>
                 </a:solidFill>
                 <a:latin typeface="IBM Plex Sans"/>
               </a:rPr>
-              <a:t>Sociedade e caixa definidos antes de comprar.</a:t>
+              <a:t>Com a entrega aceita e a margem medida, decidir a expansão.</a:t>
             </a:r>
           </a:p>
         </p:txBody>
@@ -17169,13 +17132,13 @@
               </a:spcAft>
             </a:pPr>
             <a:r>
-              <a:rPr sz="1560" b="1">
+              <a:rPr sz="1680" b="1">
                 <a:solidFill>
                   <a:srgbClr val="35105C"/>
                 </a:solidFill>
                 <a:latin typeface="IBM Plex Sans"/>
               </a:rPr>
-              <a:t>Decisão proposta: diligência e limite de risco. Não é autorização de compra.</a:t>
+              <a:t>Proposta: financiar por etapas, com sociedade e critérios acordados.</a:t>
             </a:r>
           </a:p>
         </p:txBody>
@@ -32944,7 +32907,7 @@
                 </a:solidFill>
                 <a:latin typeface="IBM Plex Sans"/>
               </a:rPr>
-              <a:t>02 / O PROBLEMA ECONÔMICO</a:t>
+              <a:t>02 / A NECESSIDADE DO COMPRADOR</a:t>
             </a:r>
           </a:p>
         </p:txBody>
@@ -33034,7 +32997,7 @@
                 </a:solidFill>
                 <a:latin typeface="IBM Plex Sans"/>
               </a:rPr>
-              <a:t>Hoje, o trabalho se perde</a:t>
+              <a:t>Ter acesso à IA não resolve</a:t>
             </a:r>
           </a:p>
           <a:p>
@@ -33056,7 +33019,7 @@
                 </a:solidFill>
                 <a:latin typeface="IBM Plex Sans"/>
               </a:rPr>
-              <a:t>entre uma ferramenta e outra.</a:t>
+              <a:t>o trabalho que fica por fazer.</a:t>
             </a:r>
           </a:p>
         </p:txBody>
@@ -33146,7 +33109,7 @@
                 </a:solidFill>
                 <a:latin typeface="IBM Plex Sans"/>
               </a:rPr>
-              <a:t>Contexto espalhado</a:t>
+              <a:t>Conteúdo parado</a:t>
             </a:r>
           </a:p>
         </p:txBody>
@@ -33191,7 +33154,7 @@
                 </a:solidFill>
                 <a:latin typeface="IBM Plex Sans"/>
               </a:rPr>
-              <a:t>Documentos, conversas e decisões em lugares diferentes.</a:t>
+              <a:t>O briefing existe. Faltam roteiro, peças e revisão para publicar.</a:t>
             </a:r>
           </a:p>
         </p:txBody>
@@ -33281,7 +33244,7 @@
                 </a:solidFill>
                 <a:latin typeface="IBM Plex Sans"/>
               </a:rPr>
-              <a:t>Produção repetida</a:t>
+              <a:t>Rotina manual</a:t>
             </a:r>
           </a:p>
         </p:txBody>
@@ -33326,7 +33289,7 @@
                 </a:solidFill>
                 <a:latin typeface="IBM Plex Sans"/>
               </a:rPr>
-              <a:t>A mesma pesquisa refeita para texto, código e resposta.</a:t>
+              <a:t>Copiar dados entre sistemas toma tempo e exige conferência.</a:t>
             </a:r>
           </a:p>
         </p:txBody>
@@ -33416,7 +33379,7 @@
                 </a:solidFill>
                 <a:latin typeface="IBM Plex Sans"/>
               </a:rPr>
-              <a:t>Revisão no fim</a:t>
+              <a:t>Dúvida repetida</a:t>
             </a:r>
           </a:p>
         </p:txBody>
@@ -33461,7 +33424,7 @@
                 </a:solidFill>
                 <a:latin typeface="IBM Plex Sans"/>
               </a:rPr>
-              <a:t>Erros e retrabalho aparecem perto da entrega.</a:t>
+              <a:t>A equipe procura a mesma política para responder ao cliente.</a:t>
             </a:r>
           </a:p>
         </p:txBody>
@@ -33506,7 +33469,7 @@
                 </a:solidFill>
                 <a:latin typeface="IBM Plex Sans"/>
               </a:rPr>
-              <a:t>Oportunidade a medir: menos retrabalho e mais entregas úteis por ciclo.</a:t>
+              <a:t>A oportunidade: vender a execução desse trabalho, com escopo e responsável.</a:t>
             </a:r>
           </a:p>
         </p:txBody>
@@ -47197,7 +47160,7 @@
                 </a:solidFill>
                 <a:latin typeface="IBM Plex Sans"/>
               </a:rPr>
-              <a:t>03 / O SISTEMA PRODUTIVO</a:t>
+              <a:t>03 / COMO VAMOS PRESTAR O SERVIÇO</a:t>
             </a:r>
           </a:p>
         </p:txBody>
@@ -47287,7 +47250,7 @@
                 </a:solidFill>
                 <a:latin typeface="IBM Plex Sans"/>
               </a:rPr>
-              <a:t>Do contexto autorizado</a:t>
+              <a:t>A AUMI assume o caminho</a:t>
             </a:r>
           </a:p>
           <a:p>
@@ -47309,7 +47272,7 @@
                 </a:solidFill>
                 <a:latin typeface="IBM Plex Sans"/>
               </a:rPr>
-              <a:t>à entrega aprovada.</a:t>
+              <a:t>entre o pedido e a entrega.</a:t>
             </a:r>
           </a:p>
         </p:txBody>
@@ -47354,7 +47317,7 @@
                 </a:solidFill>
                 <a:latin typeface="IBM Plex Sans"/>
               </a:rPr>
-              <a:t>Fontes</a:t>
+              <a:t>Entender</a:t>
             </a:r>
           </a:p>
         </p:txBody>
@@ -47399,7 +47362,7 @@
                 </a:solidFill>
                 <a:latin typeface="IBM Plex Sans"/>
               </a:rPr>
-              <a:t>Documentos, briefing</a:t>
+              <a:t>Briefing, objetivo</a:t>
             </a:r>
           </a:p>
           <a:p>
@@ -47421,7 +47384,7 @@
                 </a:solidFill>
                 <a:latin typeface="IBM Plex Sans"/>
               </a:rPr>
-              <a:t>e sistemas autorizados</a:t>
+              <a:t>e fontes autorizadas</a:t>
             </a:r>
           </a:p>
         </p:txBody>
@@ -47466,7 +47429,7 @@
                 </a:solidFill>
                 <a:latin typeface="IBM Plex Sans"/>
               </a:rPr>
-              <a:t>Agentes</a:t>
+              <a:t>Produzir</a:t>
             </a:r>
           </a:p>
         </p:txBody>
@@ -47511,7 +47474,7 @@
                 </a:solidFill>
                 <a:latin typeface="IBM Plex Sans"/>
               </a:rPr>
-              <a:t>Contexto, ferramentas</a:t>
+              <a:t>Agentes preparam</a:t>
             </a:r>
           </a:p>
           <a:p>
@@ -47533,7 +47496,7 @@
                 </a:solidFill>
                 <a:latin typeface="IBM Plex Sans"/>
               </a:rPr>
-              <a:t>e tarefas delimitadas</a:t>
+              <a:t>conteúdo, código e respostas</a:t>
             </a:r>
           </a:p>
         </p:txBody>
@@ -47578,7 +47541,7 @@
                 </a:solidFill>
                 <a:latin typeface="IBM Plex Sans"/>
               </a:rPr>
-              <a:t>Revisão</a:t>
+              <a:t>Conferir</a:t>
             </a:r>
           </a:p>
         </p:txBody>
@@ -47623,7 +47586,7 @@
                 </a:solidFill>
                 <a:latin typeface="IBM Plex Sans"/>
               </a:rPr>
-              <a:t>Especialista confere</a:t>
+              <a:t>Pessoa revisa fontes,</a:t>
             </a:r>
           </a:p>
           <a:p>
@@ -47645,7 +47608,7 @@
                 </a:solidFill>
                 <a:latin typeface="IBM Plex Sans"/>
               </a:rPr>
-              <a:t>fonte, teste e qualidade</a:t>
+              <a:t>testes e exceções</a:t>
             </a:r>
           </a:p>
         </p:txBody>
@@ -47690,7 +47653,7 @@
                 </a:solidFill>
                 <a:latin typeface="IBM Plex Sans"/>
               </a:rPr>
-              <a:t>Entrega</a:t>
+              <a:t>Entregar</a:t>
             </a:r>
           </a:p>
         </p:txBody>
@@ -47735,7 +47698,7 @@
                 </a:solidFill>
                 <a:latin typeface="IBM Plex Sans"/>
               </a:rPr>
-              <a:t>Cliente recebe</a:t>
+              <a:t>Escopo acordado,</a:t>
             </a:r>
           </a:p>
           <a:p>
@@ -47757,7 +47720,7 @@
                 </a:solidFill>
                 <a:latin typeface="IBM Plex Sans"/>
               </a:rPr>
-              <a:t>um resultado definido</a:t>
+              <a:t>aceite e responsável</a:t>
             </a:r>
           </a:p>
         </p:txBody>
@@ -47802,7 +47765,7 @@
                 </a:solidFill>
                 <a:latin typeface="IBM Plex Sans"/>
               </a:rPr>
-              <a:t>Conteúdo e código entram em produção.</a:t>
+              <a:t>A IA participa da execução.</a:t>
             </a:r>
           </a:p>
           <a:p>
@@ -47824,7 +47787,7 @@
                 </a:solidFill>
                 <a:latin typeface="IBM Plex Sans"/>
               </a:rPr>
-              <a:t>Dinheiro, contratos e publicação passam por pessoas.</a:t>
+              <a:t>A responsabilidade pela entrega continua com pessoas.</a:t>
             </a:r>
           </a:p>
         </p:txBody>
@@ -48235,7 +48198,7 @@
                 </a:solidFill>
                 <a:latin typeface="IBM Plex Sans"/>
               </a:rPr>
-              <a:t>04 / PORTFÓLIO AUMI</a:t>
+              <a:t>04 / ONDE VAMOS VENDER</a:t>
             </a:r>
           </a:p>
         </p:txBody>
@@ -48325,7 +48288,7 @@
                 </a:solidFill>
                 <a:latin typeface="IBM Plex Sans"/>
               </a:rPr>
-              <a:t>Um parque produtivo.</a:t>
+              <a:t>A mesma base pode atender</a:t>
             </a:r>
           </a:p>
           <a:p>
@@ -48347,7 +48310,7 @@
                 </a:solidFill>
                 <a:latin typeface="IBM Plex Sans"/>
               </a:rPr>
-              <a:t>Compradores e contratos distintos.</a:t>
+              <a:t>cinco frentes de receita.</a:t>
             </a:r>
           </a:p>
         </p:txBody>
@@ -48437,7 +48400,7 @@
                 </a:solidFill>
                 <a:latin typeface="IBM Plex Sans"/>
               </a:rPr>
-              <a:t>Marcas e equipes</a:t>
+              <a:t>Marketing</a:t>
             </a:r>
           </a:p>
           <a:p>
@@ -48459,7 +48422,29 @@
                 </a:solidFill>
                 <a:latin typeface="IBM Plex Sans"/>
               </a:rPr>
-              <a:t>Pacote mensal de produção</a:t>
+              <a:t>Peças e roteiros</a:t>
+            </a:r>
+          </a:p>
+          <a:p>
+            <a:pPr>
+              <a:lnSpc>
+                <a:spcPct val="112000"/>
+              </a:lnSpc>
+              <a:spcBef>
+                <a:spcPts val="0"/>
+              </a:spcBef>
+              <a:spcAft>
+                <a:spcPts val="0"/>
+              </a:spcAft>
+            </a:pPr>
+            <a:r>
+              <a:rPr sz="1739" b="0">
+                <a:solidFill>
+                  <a:srgbClr val="29143D"/>
+                </a:solidFill>
+                <a:latin typeface="IBM Plex Sans"/>
+              </a:rPr>
+              <a:t>por mês</a:t>
             </a:r>
           </a:p>
         </p:txBody>
@@ -48549,7 +48534,7 @@
                 </a:solidFill>
                 <a:latin typeface="IBM Plex Sans"/>
               </a:rPr>
-              <a:t>Operações e produto</a:t>
+              <a:t>Operações</a:t>
             </a:r>
           </a:p>
           <a:p>
@@ -48571,7 +48556,29 @@
                 </a:solidFill>
                 <a:latin typeface="IBM Plex Sans"/>
               </a:rPr>
-              <a:t>Projeto de automação</a:t>
+              <a:t>Automação de</a:t>
+            </a:r>
+          </a:p>
+          <a:p>
+            <a:pPr>
+              <a:lnSpc>
+                <a:spcPct val="112000"/>
+              </a:lnSpc>
+              <a:spcBef>
+                <a:spcPts val="0"/>
+              </a:spcBef>
+              <a:spcAft>
+                <a:spcPts val="0"/>
+              </a:spcAft>
+            </a:pPr>
+            <a:r>
+              <a:rPr sz="1739" b="0">
+                <a:solidFill>
+                  <a:srgbClr val="29143D"/>
+                </a:solidFill>
+                <a:latin typeface="IBM Plex Sans"/>
+              </a:rPr>
+              <a:t>uma rotina</a:t>
             </a:r>
           </a:p>
         </p:txBody>
@@ -48683,7 +48690,29 @@
                 </a:solidFill>
                 <a:latin typeface="IBM Plex Sans"/>
               </a:rPr>
-              <a:t>Setup + mensalidade</a:t>
+              <a:t>Base de respostas</a:t>
+            </a:r>
+          </a:p>
+          <a:p>
+            <a:pPr>
+              <a:lnSpc>
+                <a:spcPct val="112000"/>
+              </a:lnSpc>
+              <a:spcBef>
+                <a:spcPts val="0"/>
+              </a:spcBef>
+              <a:spcAft>
+                <a:spcPts val="0"/>
+              </a:spcAft>
+            </a:pPr>
+            <a:r>
+              <a:rPr sz="1739" b="0">
+                <a:solidFill>
+                  <a:srgbClr val="29143D"/>
+                </a:solidFill>
+                <a:latin typeface="IBM Plex Sans"/>
+              </a:rPr>
+              <a:t>e apoio contínuo</a:t>
             </a:r>
           </a:p>
         </p:txBody>
@@ -48773,7 +48802,7 @@
                 </a:solidFill>
                 <a:latin typeface="IBM Plex Sans"/>
               </a:rPr>
-              <a:t>Pessoas com dor específica</a:t>
+              <a:t>Consumidor final</a:t>
             </a:r>
           </a:p>
           <a:p>
@@ -48795,7 +48824,29 @@
                 </a:solidFill>
                 <a:latin typeface="IBM Plex Sans"/>
               </a:rPr>
-              <a:t>Produto digital em USD</a:t>
+              <a:t>Guias, templates</a:t>
+            </a:r>
+          </a:p>
+          <a:p>
+            <a:pPr>
+              <a:lnSpc>
+                <a:spcPct val="112000"/>
+              </a:lnSpc>
+              <a:spcBef>
+                <a:spcPts val="0"/>
+              </a:spcBef>
+              <a:spcAft>
+                <a:spcPts val="0"/>
+              </a:spcAft>
+            </a:pPr>
+            <a:r>
+              <a:rPr sz="1739" b="0">
+                <a:solidFill>
+                  <a:srgbClr val="29143D"/>
+                </a:solidFill>
+                <a:latin typeface="IBM Plex Sans"/>
+              </a:rPr>
+              <a:t>e minicursos</a:t>
             </a:r>
           </a:p>
         </p:txBody>
@@ -48885,7 +48936,7 @@
                 </a:solidFill>
                 <a:latin typeface="IBM Plex Sans"/>
               </a:rPr>
-              <a:t>TI e arquitetura</a:t>
+              <a:t>Lideranças de TI</a:t>
             </a:r>
           </a:p>
           <a:p>
@@ -48907,7 +48958,29 @@
                 </a:solidFill>
                 <a:latin typeface="IBM Plex Sans"/>
               </a:rPr>
-              <a:t>Mapa de um domínio</a:t>
+              <a:t>Mapa de sistemas</a:t>
+            </a:r>
+          </a:p>
+          <a:p>
+            <a:pPr>
+              <a:lnSpc>
+                <a:spcPct val="112000"/>
+              </a:lnSpc>
+              <a:spcBef>
+                <a:spcPts val="0"/>
+              </a:spcBef>
+              <a:spcAft>
+                <a:spcPts val="0"/>
+              </a:spcAft>
+            </a:pPr>
+            <a:r>
+              <a:rPr sz="1739" b="0">
+                <a:solidFill>
+                  <a:srgbClr val="FFFFFF"/>
+                </a:solidFill>
+                <a:latin typeface="IBM Plex Sans"/>
+              </a:rPr>
+              <a:t>e dependências</a:t>
             </a:r>
           </a:p>
         </p:txBody>
@@ -48952,7 +49025,7 @@
                 </a:solidFill>
                 <a:latin typeface="IBM Plex Sans"/>
               </a:rPr>
-              <a:t>Infraestrutura compartilhada não significa capacidade infinita.</a:t>
+              <a:t>Começar com uma oferta B2B prioritária e testes limitados de produtos próprios.</a:t>
             </a:r>
           </a:p>
         </p:txBody>
@@ -49320,7 +49393,7 @@
                 </a:solidFill>
                 <a:latin typeface="IBM Plex Sans"/>
               </a:rPr>
-              <a:t>05 / PROPOSTAS ILUSTRATIVAS</a:t>
+              <a:t>05 / EXEMPLOS DE ENTREGAS</a:t>
             </a:r>
           </a:p>
         </p:txBody>
@@ -49410,7 +49483,29 @@
                 </a:solidFill>
                 <a:latin typeface="IBM Plex Sans"/>
               </a:rPr>
-              <a:t>Veja o tipo de entrega.</a:t>
+              <a:t>O cliente precisa enxergar</a:t>
+            </a:r>
+          </a:p>
+          <a:p>
+            <a:pPr>
+              <a:lnSpc>
+                <a:spcPct val="112000"/>
+              </a:lnSpc>
+              <a:spcBef>
+                <a:spcPts val="0"/>
+              </a:spcBef>
+              <a:spcAft>
+                <a:spcPts val="0"/>
+              </a:spcAft>
+            </a:pPr>
+            <a:r>
+              <a:rPr sz="4079" b="1">
+                <a:solidFill>
+                  <a:srgbClr val="29143D"/>
+                </a:solidFill>
+                <a:latin typeface="IBM Plex Sans"/>
+              </a:rPr>
+              <a:t>o que vai receber.</a:t>
             </a:r>
           </a:p>
         </p:txBody>
@@ -49455,7 +49550,7 @@
                 </a:solidFill>
                 <a:latin typeface="IBM Plex Sans"/>
               </a:rPr>
-              <a:t>Exemplos criados para esta conversa. Não são produtos ou clientes reais.</a:t>
+              <a:t>Propostas de serviço, ainda sujeitas a validação comercial e técnica.</a:t>
             </a:r>
           </a:p>
         </p:txBody>
@@ -49657,7 +49752,7 @@
                 </a:solidFill>
                 <a:latin typeface="IBM Plex Sans"/>
               </a:rPr>
-              <a:t>IDEIA</a:t>
+              <a:t>UMA</a:t>
             </a:r>
           </a:p>
           <a:p>
@@ -49679,7 +49774,7 @@
                 </a:solidFill>
                 <a:latin typeface="IBM Plex Sans"/>
               </a:rPr>
-              <a:t>ÚTIL</a:t>
+              <a:t>OFERTA</a:t>
             </a:r>
           </a:p>
         </p:txBody>
@@ -49718,35 +49813,35 @@
               </a:spcAft>
             </a:pPr>
             <a:r>
-              <a:rPr sz="2100" b="1">
+              <a:rPr sz="1920" b="1">
                 <a:solidFill>
                   <a:srgbClr val="35105C"/>
                 </a:solidFill>
                 <a:latin typeface="IBM Plex Sans"/>
               </a:rPr>
-              <a:t>Um roteiro</a:t>
-            </a:r>
-          </a:p>
-          <a:p>
-            <a:pPr>
-              <a:lnSpc>
-                <a:spcPct val="112000"/>
-              </a:lnSpc>
-              <a:spcBef>
-                <a:spcPts val="0"/>
-              </a:spcBef>
-              <a:spcAft>
-                <a:spcPts val="0"/>
-              </a:spcAft>
-            </a:pPr>
-            <a:r>
-              <a:rPr sz="2100" b="1">
+              <a:t>Do briefing</a:t>
+            </a:r>
+          </a:p>
+          <a:p>
+            <a:pPr>
+              <a:lnSpc>
+                <a:spcPct val="112000"/>
+              </a:lnSpc>
+              <a:spcBef>
+                <a:spcPts val="0"/>
+              </a:spcBef>
+              <a:spcAft>
+                <a:spcPts val="0"/>
+              </a:spcAft>
+            </a:pPr>
+            <a:r>
+              <a:rPr sz="1920" b="1">
                 <a:solidFill>
                   <a:srgbClr val="35105C"/>
                 </a:solidFill>
                 <a:latin typeface="IBM Plex Sans"/>
               </a:rPr>
-              <a:t>vira peças.</a:t>
+              <a:t>à campanha.</a:t>
             </a:r>
           </a:p>
         </p:txBody>
@@ -49791,7 +49886,7 @@
                 </a:solidFill>
                 <a:latin typeface="IBM Plex Sans"/>
               </a:rPr>
-              <a:t>Gancho → exemplo</a:t>
+              <a:t>Roteiro e peças.</a:t>
             </a:r>
           </a:p>
           <a:p>
@@ -49813,7 +49908,7 @@
                 </a:solidFill>
                 <a:latin typeface="IBM Plex Sans"/>
               </a:rPr>
-              <a:t>→ ação sugerida</a:t>
+              <a:t>Uma revisão.</a:t>
             </a:r>
           </a:p>
           <a:p>
@@ -49835,7 +49930,7 @@
                 </a:solidFill>
                 <a:latin typeface="IBM Plex Sans"/>
               </a:rPr>
-              <a:t>→ revisão</a:t>
+              <a:t>Aceite do cliente.</a:t>
             </a:r>
           </a:p>
         </p:txBody>
@@ -49880,7 +49975,7 @@
                 </a:solidFill>
                 <a:latin typeface="IBM Plex Sans"/>
               </a:rPr>
-              <a:t>entrada autorizada</a:t>
+              <a:t>Dados de entrada</a:t>
             </a:r>
           </a:p>
           <a:p>
@@ -49924,7 +50019,7 @@
                 </a:solidFill>
                 <a:latin typeface="IBM Plex Sans"/>
               </a:rPr>
-              <a:t>validar → transformar</a:t>
+              <a:t>validar e transformar</a:t>
             </a:r>
           </a:p>
           <a:p>
@@ -49968,7 +50063,7 @@
                 </a:solidFill>
                 <a:latin typeface="IBM Plex Sans"/>
               </a:rPr>
-              <a:t>exceção → revisão</a:t>
+              <a:t>separar exceções</a:t>
             </a:r>
           </a:p>
         </p:txBody>
@@ -50080,7 +50175,7 @@
                 </a:solidFill>
                 <a:latin typeface="IBM Plex Sans"/>
               </a:rPr>
-              <a:t>Responde com fonte.</a:t>
+              <a:t>Prepara a resposta.</a:t>
             </a:r>
           </a:p>
           <a:p>
@@ -50147,7 +50242,7 @@
                 </a:solidFill>
                 <a:latin typeface="IBM Plex Sans"/>
               </a:rPr>
-              <a:t>Não prometer alcance, automação sem erro ou atendimento ilimitado.</a:t>
+              <a:t>Cada proposta define entrega, limite, revisão e critério de aceite.</a:t>
             </a:r>
           </a:p>
         </p:txBody>
@@ -50429,7 +50524,7 @@
                 </a:solidFill>
                 <a:latin typeface="IBM Plex Sans"/>
               </a:rPr>
-              <a:t>06 / PRODUTOS PRÓPRIOS</a:t>
+              <a:t>06 / LOJA DE PRODUTOS DIGITAIS</a:t>
             </a:r>
           </a:p>
         </p:txBody>
@@ -50474,7 +50569,7 @@
                 </a:solidFill>
                 <a:latin typeface="IBM Plex Sans"/>
               </a:rPr>
-              <a:t>Loja LATAM:</a:t>
+              <a:t>Criar produtos</a:t>
             </a:r>
           </a:p>
           <a:p>
@@ -50496,7 +50591,7 @@
                 </a:solidFill>
                 <a:latin typeface="IBM Plex Sans"/>
               </a:rPr>
-              <a:t>validar antes de</a:t>
+              <a:t>que possam ser</a:t>
             </a:r>
           </a:p>
           <a:p>
@@ -50518,7 +50613,7 @@
                 </a:solidFill>
                 <a:latin typeface="IBM Plex Sans"/>
               </a:rPr>
-              <a:t>multiplicar.</a:t>
+              <a:t>vendidos de novo.</a:t>
             </a:r>
           </a:p>
         </p:txBody>
@@ -50576,61 +50671,61 @@
         </p:nvSpPr>
         <p:spPr>
           <a:xfrm>
-            <a:off x="601980" y="2697480"/>
-            <a:ext cx="5600700" cy="906780"/>
-          </a:xfrm>
-          <a:prstGeom prst="rect">
-            <a:avLst/>
-          </a:prstGeom>
-          <a:noFill/>
-        </p:spPr>
-        <p:txBody>
-          <a:bodyPr wrap="square" lIns="0" rIns="0" tIns="0" bIns="0">
-            <a:spAutoFit/>
-          </a:bodyPr>
-          <a:lstStyle/>
-          <a:p>
-            <a:pPr>
-              <a:lnSpc>
-                <a:spcPct val="112000"/>
-              </a:lnSpc>
-              <a:spcBef>
-                <a:spcPts val="0"/>
-              </a:spcBef>
-              <a:spcAft>
-                <a:spcPts val="0"/>
-              </a:spcAft>
-            </a:pPr>
-            <a:r>
-              <a:rPr sz="2580" b="1">
+            <a:off x="601980" y="2971800"/>
+            <a:ext cx="5600700" cy="762000"/>
+          </a:xfrm>
+          <a:prstGeom prst="rect">
+            <a:avLst/>
+          </a:prstGeom>
+          <a:noFill/>
+        </p:spPr>
+        <p:txBody>
+          <a:bodyPr wrap="square" lIns="0" rIns="0" tIns="0" bIns="0">
+            <a:spAutoFit/>
+          </a:bodyPr>
+          <a:lstStyle/>
+          <a:p>
+            <a:pPr>
+              <a:lnSpc>
+                <a:spcPct val="112000"/>
+              </a:lnSpc>
+              <a:spcBef>
+                <a:spcPts val="0"/>
+              </a:spcBef>
+              <a:spcAft>
+                <a:spcPts val="0"/>
+              </a:spcAft>
+            </a:pPr>
+            <a:r>
+              <a:rPr sz="2280" b="1">
                 <a:solidFill>
                   <a:srgbClr val="35105C"/>
                 </a:solidFill>
                 <a:latin typeface="IBM Plex Sans"/>
               </a:rPr>
-              <a:t>PDFs práticos, templates,</a:t>
-            </a:r>
-          </a:p>
-          <a:p>
-            <a:pPr>
-              <a:lnSpc>
-                <a:spcPct val="112000"/>
-              </a:lnSpc>
-              <a:spcBef>
-                <a:spcPts val="0"/>
-              </a:spcBef>
-              <a:spcAft>
-                <a:spcPts val="0"/>
-              </a:spcAft>
-            </a:pPr>
-            <a:r>
-              <a:rPr sz="2580" b="1">
+              <a:t>Guias práticos, templates,</a:t>
+            </a:r>
+          </a:p>
+          <a:p>
+            <a:pPr>
+              <a:lnSpc>
+                <a:spcPct val="112000"/>
+              </a:lnSpc>
+              <a:spcBef>
+                <a:spcPts val="0"/>
+              </a:spcBef>
+              <a:spcAft>
+                <a:spcPts val="0"/>
+              </a:spcAft>
+            </a:pPr>
+            <a:r>
+              <a:rPr sz="2280" b="1">
                 <a:solidFill>
                   <a:srgbClr val="35105C"/>
                 </a:solidFill>
                 <a:latin typeface="IBM Plex Sans"/>
               </a:rPr>
-              <a:t>kits e minicursos.</a:t>
+              <a:t>kits e minicursos para LATAM.</a:t>
             </a:r>
           </a:p>
         </p:txBody>
@@ -50643,83 +50738,83 @@
         </p:nvSpPr>
         <p:spPr>
           <a:xfrm>
-            <a:off x="601980" y="4038600"/>
-            <a:ext cx="5562600" cy="1249680"/>
-          </a:xfrm>
-          <a:prstGeom prst="rect">
-            <a:avLst/>
-          </a:prstGeom>
-          <a:noFill/>
-        </p:spPr>
-        <p:txBody>
-          <a:bodyPr wrap="square" lIns="0" rIns="0" tIns="0" bIns="0">
-            <a:spAutoFit/>
-          </a:bodyPr>
-          <a:lstStyle/>
-          <a:p>
-            <a:pPr>
-              <a:lnSpc>
-                <a:spcPct val="112000"/>
-              </a:lnSpc>
-              <a:spcBef>
-                <a:spcPts val="0"/>
-              </a:spcBef>
-              <a:spcAft>
-                <a:spcPts val="0"/>
-              </a:spcAft>
-            </a:pPr>
-            <a:r>
-              <a:rPr sz="2100" b="0">
+            <a:off x="601980" y="4130040"/>
+            <a:ext cx="5562600" cy="1127760"/>
+          </a:xfrm>
+          <a:prstGeom prst="rect">
+            <a:avLst/>
+          </a:prstGeom>
+          <a:noFill/>
+        </p:spPr>
+        <p:txBody>
+          <a:bodyPr wrap="square" lIns="0" rIns="0" tIns="0" bIns="0">
+            <a:spAutoFit/>
+          </a:bodyPr>
+          <a:lstStyle/>
+          <a:p>
+            <a:pPr>
+              <a:lnSpc>
+                <a:spcPct val="112000"/>
+              </a:lnSpc>
+              <a:spcBef>
+                <a:spcPts val="0"/>
+              </a:spcBef>
+              <a:spcAft>
+                <a:spcPts val="0"/>
+              </a:spcAft>
+            </a:pPr>
+            <a:r>
+              <a:rPr sz="2039" b="0">
                 <a:solidFill>
                   <a:srgbClr val="29143D"/>
                 </a:solidFill>
                 <a:latin typeface="IBM Plex Sans"/>
               </a:rPr>
-              <a:t>Até 3 nichos em teste.</a:t>
-            </a:r>
-          </a:p>
-          <a:p>
-            <a:pPr>
-              <a:lnSpc>
-                <a:spcPct val="112000"/>
-              </a:lnSpc>
-              <a:spcBef>
-                <a:spcPts val="0"/>
-              </a:spcBef>
-              <a:spcAft>
-                <a:spcPts val="0"/>
-              </a:spcAft>
-            </a:pPr>
-            <a:r>
-              <a:rPr sz="2100" b="0">
+              <a:t>Testar até 3 nichos.</a:t>
+            </a:r>
+          </a:p>
+          <a:p>
+            <a:pPr>
+              <a:lnSpc>
+                <a:spcPct val="112000"/>
+              </a:lnSpc>
+              <a:spcBef>
+                <a:spcPts val="0"/>
+              </a:spcBef>
+              <a:spcAft>
+                <a:spcPts val="0"/>
+              </a:spcAft>
+            </a:pPr>
+            <a:r>
+              <a:rPr sz="2039" b="0">
                 <a:solidFill>
                   <a:srgbClr val="29143D"/>
                 </a:solidFill>
                 <a:latin typeface="IBM Plex Sans"/>
               </a:rPr>
-              <a:t>Oferta curta, revisão especializada</a:t>
-            </a:r>
-          </a:p>
-          <a:p>
-            <a:pPr>
-              <a:lnSpc>
-                <a:spcPct val="112000"/>
-              </a:lnSpc>
-              <a:spcBef>
-                <a:spcPts val="0"/>
-              </a:spcBef>
-              <a:spcAft>
-                <a:spcPts val="0"/>
-              </a:spcAft>
-            </a:pPr>
-            <a:r>
-              <a:rPr sz="2100" b="0">
+              <a:t>Produzir uma solução útil.</a:t>
+            </a:r>
+          </a:p>
+          <a:p>
+            <a:pPr>
+              <a:lnSpc>
+                <a:spcPct val="112000"/>
+              </a:lnSpc>
+              <a:spcBef>
+                <a:spcPts val="0"/>
+              </a:spcBef>
+              <a:spcAft>
+                <a:spcPts val="0"/>
+              </a:spcAft>
+            </a:pPr>
+            <a:r>
+              <a:rPr sz="2039" b="0">
                 <a:solidFill>
                   <a:srgbClr val="29143D"/>
                 </a:solidFill>
                 <a:latin typeface="IBM Plex Sans"/>
               </a:rPr>
-              <a:t>e checkout existente.</a:t>
+              <a:t>Vender por checkout existente.</a:t>
             </a:r>
           </a:p>
         </p:txBody>
@@ -50809,7 +50904,7 @@
                 </a:solidFill>
                 <a:latin typeface="IBM Plex Sans"/>
               </a:rPr>
-              <a:t>Ticket médio hipotético.</a:t>
+              <a:t>Ticket médio usado</a:t>
             </a:r>
           </a:p>
           <a:p>
@@ -50831,7 +50926,7 @@
                 </a:solidFill>
                 <a:latin typeface="IBM Plex Sans"/>
               </a:rPr>
-              <a:t>Não é preço já validado.</a:t>
+              <a:t>na simulação.</a:t>
             </a:r>
           </a:p>
         </p:txBody>
@@ -50876,7 +50971,7 @@
                 </a:solidFill>
                 <a:latin typeface="IBM Plex Sans"/>
               </a:rPr>
-              <a:t>Medir CAC, estornos e suporte.</a:t>
+              <a:t>Cada venda paga aquisição,</a:t>
             </a:r>
           </a:p>
           <a:p>
@@ -50898,7 +50993,7 @@
                 </a:solidFill>
                 <a:latin typeface="IBM Plex Sans"/>
               </a:rPr>
-              <a:t>Parar se não houver margem</a:t>
+              <a:t>plataforma e suporte.</a:t>
             </a:r>
           </a:p>
           <a:p>
@@ -50920,7 +51015,7 @@
                 </a:solidFill>
                 <a:latin typeface="IBM Plex Sans"/>
               </a:rPr>
-              <a:t>ou qualidade suficiente.</a:t>
+              <a:t>Repetir só com margem.</a:t>
             </a:r>
           </a:p>
         </p:txBody>
@@ -50965,7 +51060,7 @@
                 </a:solidFill>
                 <a:latin typeface="IBM Plex Sans"/>
               </a:rPr>
-              <a:t>Nenhum catálogo pronto ou nicho escolhido. Espanhol é hipótese inicial.</a:t>
+              <a:t>Primeiro, provar uma oferta. Depois, ampliar o catálogo. Nichos ainda a definir.</a:t>
             </a:r>
           </a:p>
         </p:txBody>
@@ -51441,7 +51536,7 @@
                 </a:solidFill>
                 <a:latin typeface="IBM Plex Sans"/>
               </a:rPr>
-              <a:t>07 / MAPA INICIAL DE TI</a:t>
+              <a:t>07 / UM SERVIÇO DE MAIOR VALOR</a:t>
             </a:r>
           </a:p>
         </p:txBody>
@@ -51531,7 +51626,7 @@
                 </a:solidFill>
                 <a:latin typeface="IBM Plex Sans"/>
               </a:rPr>
-              <a:t>Topologic: enxergar relações</a:t>
+              <a:t>Topologic: saber o que depende</a:t>
             </a:r>
           </a:p>
           <a:p>
@@ -51553,7 +51648,7 @@
                 </a:solidFill>
                 <a:latin typeface="IBM Plex Sans"/>
               </a:rPr>
-              <a:t>antes de decidir uma mudança.</a:t>
+              <a:t>de quê antes de mudar a TI.</a:t>
             </a:r>
           </a:p>
         </p:txBody>
@@ -52003,7 +52098,7 @@
                 </a:solidFill>
                 <a:latin typeface="IBM Plex Sans"/>
               </a:rPr>
-              <a:t>80h diretas • 1 domínio</a:t>
+              <a:t>Mapa inicial de um domínio.</a:t>
             </a:r>
           </a:p>
           <a:p>
@@ -52025,7 +52120,7 @@
                 </a:solidFill>
                 <a:latin typeface="IBM Plex Sans"/>
               </a:rPr>
-              <a:t>Até 40 sistemas / 80 relações</a:t>
+              <a:t>Até 40 sistemas / 80 relações.</a:t>
             </a:r>
           </a:p>
           <a:p>
@@ -52047,7 +52142,7 @@
                 </a:solidFill>
                 <a:latin typeface="IBM Plex Sans"/>
               </a:rPr>
-              <a:t>2 fontes / 2 validações</a:t>
+              <a:t>80h diretas; preço proposto.</a:t>
             </a:r>
           </a:p>
         </p:txBody>
@@ -52092,7 +52187,7 @@
                 </a:solidFill>
                 <a:latin typeface="IBM Plex Sans"/>
               </a:rPr>
-              <a:t>Inventário + mapa + lacunas</a:t>
+              <a:t>Sistemas, dependências e lacunas</a:t>
             </a:r>
           </a:p>
           <a:p>
@@ -52114,7 +52209,7 @@
                 </a:solidFill>
                 <a:latin typeface="IBM Plex Sans"/>
               </a:rPr>
-              <a:t>+ PDF executivo + exportação.</a:t>
+              <a:t>em um material para decisão.</a:t>
             </a:r>
           </a:p>
         </p:txBody>
@@ -52310,7 +52405,7 @@
                 </a:solidFill>
                 <a:latin typeface="IBM Plex Sans"/>
               </a:rPr>
-              <a:t>08 / MODELO COMERCIAL</a:t>
+              <a:t>08 / COMO A RECEITA ENTRA</a:t>
             </a:r>
           </a:p>
         </p:txBody>
@@ -52400,7 +52495,7 @@
                 </a:solidFill>
                 <a:latin typeface="IBM Plex Sans"/>
               </a:rPr>
-              <a:t>Projetos. Recorrência.</a:t>
+              <a:t>Cobrar pela entrega.</a:t>
             </a:r>
           </a:p>
           <a:p>
@@ -52422,7 +52517,7 @@
                 </a:solidFill>
                 <a:latin typeface="IBM Plex Sans"/>
               </a:rPr>
-              <a:t>Produtos próprios.</a:t>
+              <a:t>Renovar pelo trabalho contínuo.</a:t>
             </a:r>
           </a:p>
         </p:txBody>
@@ -52467,7 +52562,7 @@
                 </a:solidFill>
                 <a:latin typeface="IBM Plex Sans"/>
               </a:rPr>
-              <a:t>PROJETOS</a:t>
+              <a:t>POR PROJETO</a:t>
             </a:r>
           </a:p>
         </p:txBody>
@@ -52557,7 +52652,7 @@
                 </a:solidFill>
                 <a:latin typeface="IBM Plex Sans"/>
               </a:rPr>
-              <a:t>Código / mapa TI</a:t>
+              <a:t>Automação / mapa de TI.</a:t>
             </a:r>
           </a:p>
           <a:p>
@@ -52579,7 +52674,7 @@
                 </a:solidFill>
                 <a:latin typeface="IBM Plex Sans"/>
               </a:rPr>
-              <a:t>Escopo e aceite definidos</a:t>
+              <a:t>Escopo fechado e aceite.</a:t>
             </a:r>
           </a:p>
         </p:txBody>
@@ -52624,7 +52719,7 @@
                 </a:solidFill>
                 <a:latin typeface="IBM Plex Sans"/>
               </a:rPr>
-              <a:t>RECORRÊNCIA</a:t>
+              <a:t>POR MÊS</a:t>
             </a:r>
           </a:p>
         </p:txBody>
@@ -52714,7 +52809,7 @@
                 </a:solidFill>
                 <a:latin typeface="IBM Plex Sans"/>
               </a:rPr>
-              <a:t>Conteúdo / atendimento</a:t>
+              <a:t>Conteúdo / atendimento.</a:t>
             </a:r>
           </a:p>
           <a:p>
@@ -52736,7 +52831,7 @@
                 </a:solidFill>
                 <a:latin typeface="IBM Plex Sans"/>
               </a:rPr>
-              <a:t>Atendimento: setup R$ 6k</a:t>
+              <a:t>Setup do atendimento: R$ 6k.</a:t>
             </a:r>
           </a:p>
         </p:txBody>
@@ -52781,7 +52876,7 @@
                 </a:solidFill>
                 <a:latin typeface="IBM Plex Sans"/>
               </a:rPr>
-              <a:t>PRODUTO PRÓPRIO</a:t>
+              <a:t>POR VENDA</a:t>
             </a:r>
           </a:p>
         </p:txBody>
@@ -52871,7 +52966,7 @@
                 </a:solidFill>
                 <a:latin typeface="IBM Plex Sans"/>
               </a:rPr>
-              <a:t>Loja LATAM</a:t>
+              <a:t>Produto digital próprio.</a:t>
             </a:r>
           </a:p>
           <a:p>
@@ -52893,7 +52988,7 @@
                 </a:solidFill>
                 <a:latin typeface="IBM Plex Sans"/>
               </a:rPr>
-              <a:t>Por pedido aprovado</a:t>
+              <a:t>Ticket médio simulado.</a:t>
             </a:r>
           </a:p>
         </p:txBody>
@@ -52938,7 +53033,7 @@
                 </a:solidFill>
                 <a:latin typeface="IBM Plex Sans"/>
               </a:rPr>
-              <a:t>Todos os preços são hipóteses comerciais. Não há contratos comprovados.</a:t>
+              <a:t>Preços para testar com compradores. Receita recorrente exige renovação.</a:t>
             </a:r>
           </a:p>
         </p:txBody>

</xml_diff>